<commit_message>
presentation on PIE region zoom 1
</commit_message>
<xml_diff>
--- a/presentations/PIEzoomed1.pptx
+++ b/presentations/PIEzoomed1.pptx
@@ -5,30 +5,28 @@
     <p:sldMasterId id="2147483648" r:id="rId1"/>
   </p:sldMasterIdLst>
   <p:notesMasterIdLst>
-    <p:notesMasterId r:id="rId23"/>
+    <p:notesMasterId r:id="rId21"/>
   </p:notesMasterIdLst>
   <p:sldIdLst>
     <p:sldId id="269" r:id="rId2"/>
-    <p:sldId id="270" r:id="rId3"/>
-    <p:sldId id="271" r:id="rId4"/>
-    <p:sldId id="272" r:id="rId5"/>
-    <p:sldId id="273" r:id="rId6"/>
-    <p:sldId id="274" r:id="rId7"/>
-    <p:sldId id="275" r:id="rId8"/>
-    <p:sldId id="276" r:id="rId9"/>
-    <p:sldId id="277" r:id="rId10"/>
-    <p:sldId id="256" r:id="rId11"/>
-    <p:sldId id="259" r:id="rId12"/>
-    <p:sldId id="258" r:id="rId13"/>
-    <p:sldId id="260" r:id="rId14"/>
-    <p:sldId id="261" r:id="rId15"/>
-    <p:sldId id="262" r:id="rId16"/>
-    <p:sldId id="263" r:id="rId17"/>
-    <p:sldId id="264" r:id="rId18"/>
-    <p:sldId id="265" r:id="rId19"/>
-    <p:sldId id="266" r:id="rId20"/>
-    <p:sldId id="267" r:id="rId21"/>
-    <p:sldId id="268" r:id="rId22"/>
+    <p:sldId id="271" r:id="rId3"/>
+    <p:sldId id="272" r:id="rId4"/>
+    <p:sldId id="273" r:id="rId5"/>
+    <p:sldId id="274" r:id="rId6"/>
+    <p:sldId id="275" r:id="rId7"/>
+    <p:sldId id="276" r:id="rId8"/>
+    <p:sldId id="256" r:id="rId9"/>
+    <p:sldId id="259" r:id="rId10"/>
+    <p:sldId id="258" r:id="rId11"/>
+    <p:sldId id="260" r:id="rId12"/>
+    <p:sldId id="261" r:id="rId13"/>
+    <p:sldId id="262" r:id="rId14"/>
+    <p:sldId id="263" r:id="rId15"/>
+    <p:sldId id="264" r:id="rId16"/>
+    <p:sldId id="265" r:id="rId17"/>
+    <p:sldId id="266" r:id="rId18"/>
+    <p:sldId id="267" r:id="rId19"/>
+    <p:sldId id="268" r:id="rId20"/>
   </p:sldIdLst>
   <p:sldSz cx="12192000" cy="6858000"/>
   <p:notesSz cx="6858000" cy="9144000"/>
@@ -127,6 +125,11 @@
       </a:defRPr>
     </a:lvl9pPr>
   </p:defaultTextStyle>
+  <p:extLst>
+    <p:ext uri="{EFAFB233-063F-42B5-8137-9DF3F51BA10A}">
+      <p15:sldGuideLst xmlns:p15="http://schemas.microsoft.com/office/powerpoint/2012/main"/>
+    </p:ext>
+  </p:extLst>
 </p:presentation>
 </file>
 
@@ -212,7 +215,7 @@
           <a:p>
             <a:fld id="{0C7CE4C4-5896-4426-BACC-815CF1752878}" type="datetimeFigureOut">
               <a:rPr lang="en-US" smtClean="0"/>
-              <a:t>10/28/2025</a:t>
+              <a:t>10/29/2025</a:t>
             </a:fld>
             <a:endParaRPr lang="en-US"/>
           </a:p>
@@ -626,7 +629,7 @@
           <a:p>
             <a:fld id="{56CABB3A-080B-43CC-90C9-E48FC4D4372B}" type="datetime1">
               <a:rPr lang="en-US" smtClean="0"/>
-              <a:t>10/28/2025</a:t>
+              <a:t>10/29/2025</a:t>
             </a:fld>
             <a:endParaRPr lang="en-US"/>
           </a:p>
@@ -824,7 +827,7 @@
           <a:p>
             <a:fld id="{51D94C8C-67AA-4A84-9D0A-402329E37964}" type="datetime1">
               <a:rPr lang="en-US" smtClean="0"/>
-              <a:t>10/28/2025</a:t>
+              <a:t>10/29/2025</a:t>
             </a:fld>
             <a:endParaRPr lang="en-US"/>
           </a:p>
@@ -1032,7 +1035,7 @@
           <a:p>
             <a:fld id="{04928BEF-598C-4015-ABE1-D56E6877D735}" type="datetime1">
               <a:rPr lang="en-US" smtClean="0"/>
-              <a:t>10/28/2025</a:t>
+              <a:t>10/29/2025</a:t>
             </a:fld>
             <a:endParaRPr lang="en-US"/>
           </a:p>
@@ -1230,7 +1233,7 @@
           <a:p>
             <a:fld id="{68916750-84E8-437B-BA55-2064CB0CF43E}" type="datetime1">
               <a:rPr lang="en-US" smtClean="0"/>
-              <a:t>10/28/2025</a:t>
+              <a:t>10/29/2025</a:t>
             </a:fld>
             <a:endParaRPr lang="en-US"/>
           </a:p>
@@ -1505,7 +1508,7 @@
           <a:p>
             <a:fld id="{65224CDE-964A-483C-BA2D-95C5D43F8DCE}" type="datetime1">
               <a:rPr lang="en-US" smtClean="0"/>
-              <a:t>10/28/2025</a:t>
+              <a:t>10/29/2025</a:t>
             </a:fld>
             <a:endParaRPr lang="en-US"/>
           </a:p>
@@ -1770,7 +1773,7 @@
           <a:p>
             <a:fld id="{9F4065D2-F412-4AB9-A2C6-35359F9BA1CF}" type="datetime1">
               <a:rPr lang="en-US" smtClean="0"/>
-              <a:t>10/28/2025</a:t>
+              <a:t>10/29/2025</a:t>
             </a:fld>
             <a:endParaRPr lang="en-US"/>
           </a:p>
@@ -2182,7 +2185,7 @@
           <a:p>
             <a:fld id="{C9E18ECB-F4C4-4B30-B4D6-DD0F15F018C5}" type="datetime1">
               <a:rPr lang="en-US" smtClean="0"/>
-              <a:t>10/28/2025</a:t>
+              <a:t>10/29/2025</a:t>
             </a:fld>
             <a:endParaRPr lang="en-US"/>
           </a:p>
@@ -2323,7 +2326,7 @@
           <a:p>
             <a:fld id="{5C102DBA-7C12-4999-9BEE-7615F2E0A6CC}" type="datetime1">
               <a:rPr lang="en-US" smtClean="0"/>
-              <a:t>10/28/2025</a:t>
+              <a:t>10/29/2025</a:t>
             </a:fld>
             <a:endParaRPr lang="en-US"/>
           </a:p>
@@ -2436,7 +2439,7 @@
           <a:p>
             <a:fld id="{98449FA5-525D-4324-98C8-0ED1D83B046A}" type="datetime1">
               <a:rPr lang="en-US" smtClean="0"/>
-              <a:t>10/28/2025</a:t>
+              <a:t>10/29/2025</a:t>
             </a:fld>
             <a:endParaRPr lang="en-US"/>
           </a:p>
@@ -2747,7 +2750,7 @@
           <a:p>
             <a:fld id="{439B51B4-3409-4B73-9E8A-C91F391D7429}" type="datetime1">
               <a:rPr lang="en-US" smtClean="0"/>
-              <a:t>10/28/2025</a:t>
+              <a:t>10/29/2025</a:t>
             </a:fld>
             <a:endParaRPr lang="en-US"/>
           </a:p>
@@ -3035,7 +3038,7 @@
           <a:p>
             <a:fld id="{03E2313A-39A8-4B3D-AEB2-DEF34F2617B4}" type="datetime1">
               <a:rPr lang="en-US" smtClean="0"/>
-              <a:t>10/28/2025</a:t>
+              <a:t>10/29/2025</a:t>
             </a:fld>
             <a:endParaRPr lang="en-US"/>
           </a:p>
@@ -3276,7 +3279,7 @@
           <a:p>
             <a:fld id="{12DA3BF3-6D5D-4665-B3E0-2909FCF356E2}" type="datetime1">
               <a:rPr lang="en-US" smtClean="0"/>
-              <a:t>10/28/2025</a:t>
+              <a:t>10/29/2025</a:t>
             </a:fld>
             <a:endParaRPr lang="en-US"/>
           </a:p>
@@ -3764,7 +3767,7 @@
                 <a:latin typeface="Times New Roman" panose="02020603050405020304" pitchFamily="18" charset="0"/>
                 <a:cs typeface="Times New Roman" panose="02020603050405020304" pitchFamily="18" charset="0"/>
               </a:rPr>
-              <a:t>Raster results were made using the code.</a:t>
+              <a:t>Code made the raster results.</a:t>
             </a:r>
             <a:br>
               <a:rPr lang="en-US" dirty="0">
@@ -3777,7 +3780,7 @@
                 <a:latin typeface="Times New Roman" panose="02020603050405020304" pitchFamily="18" charset="0"/>
                 <a:cs typeface="Times New Roman" panose="02020603050405020304" pitchFamily="18" charset="0"/>
               </a:rPr>
-              <a:t>Maps were made using QGIS.</a:t>
+              <a:t>QGIS made the maps.</a:t>
             </a:r>
           </a:p>
         </p:txBody>
@@ -3846,308 +3849,6 @@
           <p:cNvPr id="4" name="Title 3">
             <a:extLst>
               <a:ext uri="{FF2B5EF4-FFF2-40B4-BE49-F238E27FC236}">
-                <a16:creationId xmlns:a16="http://schemas.microsoft.com/office/drawing/2014/main" id="{2A70CDE9-EA15-4B71-94FB-6A4F4E1C4255}"/>
-              </a:ext>
-            </a:extLst>
-          </p:cNvPr>
-          <p:cNvSpPr>
-            <a:spLocks noGrp="1"/>
-          </p:cNvSpPr>
-          <p:nvPr>
-            <p:ph type="title"/>
-          </p:nvPr>
-        </p:nvSpPr>
-        <p:spPr/>
-        <p:txBody>
-          <a:bodyPr/>
-          <a:lstStyle/>
-          <a:p>
-            <a:r>
-              <a:rPr lang="en-US" dirty="0">
-                <a:latin typeface="Times New Roman" panose="02020603050405020304" pitchFamily="18" charset="0"/>
-                <a:cs typeface="Times New Roman" panose="02020603050405020304" pitchFamily="18" charset="0"/>
-              </a:rPr>
-              <a:t>Toy data</a:t>
-            </a:r>
-          </a:p>
-        </p:txBody>
-      </p:sp>
-      <p:sp>
-        <p:nvSpPr>
-          <p:cNvPr id="5" name="Text Placeholder 4">
-            <a:extLst>
-              <a:ext uri="{FF2B5EF4-FFF2-40B4-BE49-F238E27FC236}">
-                <a16:creationId xmlns:a16="http://schemas.microsoft.com/office/drawing/2014/main" id="{FF2B6C68-14CF-4FB7-8173-9989FBC807A8}"/>
-              </a:ext>
-            </a:extLst>
-          </p:cNvPr>
-          <p:cNvSpPr>
-            <a:spLocks noGrp="1"/>
-          </p:cNvSpPr>
-          <p:nvPr>
-            <p:ph type="body" idx="1"/>
-          </p:nvPr>
-        </p:nvSpPr>
-        <p:spPr/>
-        <p:txBody>
-          <a:bodyPr/>
-          <a:lstStyle/>
-          <a:p>
-            <a:endParaRPr lang="en-US"/>
-          </a:p>
-        </p:txBody>
-      </p:sp>
-      <p:sp>
-        <p:nvSpPr>
-          <p:cNvPr id="6" name="Slide Number Placeholder 5">
-            <a:extLst>
-              <a:ext uri="{FF2B5EF4-FFF2-40B4-BE49-F238E27FC236}">
-                <a16:creationId xmlns:a16="http://schemas.microsoft.com/office/drawing/2014/main" id="{B958B965-FF81-48C5-84FB-E00D7D4E3B53}"/>
-              </a:ext>
-            </a:extLst>
-          </p:cNvPr>
-          <p:cNvSpPr>
-            <a:spLocks noGrp="1"/>
-          </p:cNvSpPr>
-          <p:nvPr>
-            <p:ph type="sldNum" sz="quarter" idx="12"/>
-          </p:nvPr>
-        </p:nvSpPr>
-        <p:spPr/>
-        <p:txBody>
-          <a:bodyPr/>
-          <a:lstStyle/>
-          <a:p>
-            <a:fld id="{2BB7EF4A-24AD-40B4-BD2D-14812ACD731E}" type="slidenum">
-              <a:rPr lang="en-US" smtClean="0"/>
-              <a:t>10</a:t>
-            </a:fld>
-            <a:endParaRPr lang="en-US"/>
-          </a:p>
-        </p:txBody>
-      </p:sp>
-    </p:spTree>
-    <p:extLst>
-      <p:ext uri="{BB962C8B-B14F-4D97-AF65-F5344CB8AC3E}">
-        <p14:creationId xmlns:p14="http://schemas.microsoft.com/office/powerpoint/2010/main" val="125500990"/>
-      </p:ext>
-    </p:extLst>
-  </p:cSld>
-  <p:clrMapOvr>
-    <a:masterClrMapping/>
-  </p:clrMapOvr>
-</p:sld>
-</file>
-
-<file path=ppt/slides/slide11.xml><?xml version="1.0" encoding="utf-8"?>
-<p:sld xmlns:a="http://schemas.openxmlformats.org/drawingml/2006/main" xmlns:r="http://schemas.openxmlformats.org/officeDocument/2006/relationships" xmlns:p="http://schemas.openxmlformats.org/presentationml/2006/main">
-  <p:cSld>
-    <p:spTree>
-      <p:nvGrpSpPr>
-        <p:cNvPr id="1" name=""/>
-        <p:cNvGrpSpPr/>
-        <p:nvPr/>
-      </p:nvGrpSpPr>
-      <p:grpSpPr>
-        <a:xfrm>
-          <a:off x="0" y="0"/>
-          <a:ext cx="0" cy="0"/>
-          <a:chOff x="0" y="0"/>
-          <a:chExt cx="0" cy="0"/>
-        </a:xfrm>
-      </p:grpSpPr>
-      <p:sp>
-        <p:nvSpPr>
-          <p:cNvPr id="4" name="Title 3">
-            <a:extLst>
-              <a:ext uri="{FF2B5EF4-FFF2-40B4-BE49-F238E27FC236}">
-                <a16:creationId xmlns:a16="http://schemas.microsoft.com/office/drawing/2014/main" id="{1C68413C-C38E-462C-B839-0136E5FC851B}"/>
-              </a:ext>
-            </a:extLst>
-          </p:cNvPr>
-          <p:cNvSpPr>
-            <a:spLocks noGrp="1"/>
-          </p:cNvSpPr>
-          <p:nvPr>
-            <p:ph type="title"/>
-          </p:nvPr>
-        </p:nvSpPr>
-        <p:spPr/>
-        <p:txBody>
-          <a:bodyPr/>
-          <a:lstStyle/>
-          <a:p>
-            <a:r>
-              <a:rPr lang="en-US" dirty="0">
-                <a:latin typeface="Times New Roman" panose="02020603050405020304" pitchFamily="18" charset="0"/>
-                <a:cs typeface="Times New Roman" panose="02020603050405020304" pitchFamily="18" charset="0"/>
-              </a:rPr>
-              <a:t>Presence and Sum</a:t>
-            </a:r>
-          </a:p>
-        </p:txBody>
-      </p:sp>
-      <p:pic>
-        <p:nvPicPr>
-          <p:cNvPr id="7" name="Picture 6">
-            <a:extLst>
-              <a:ext uri="{FF2B5EF4-FFF2-40B4-BE49-F238E27FC236}">
-                <a16:creationId xmlns:a16="http://schemas.microsoft.com/office/drawing/2014/main" id="{C7CA9375-DFE4-438F-9115-501A20F14872}"/>
-              </a:ext>
-            </a:extLst>
-          </p:cNvPr>
-          <p:cNvPicPr>
-            <a:picLocks noChangeAspect="1"/>
-          </p:cNvPicPr>
-          <p:nvPr/>
-        </p:nvPicPr>
-        <p:blipFill>
-          <a:blip r:embed="rId2"/>
-          <a:stretch>
-            <a:fillRect/>
-          </a:stretch>
-        </p:blipFill>
-        <p:spPr>
-          <a:xfrm>
-            <a:off x="3535473" y="3034947"/>
-            <a:ext cx="5236579" cy="2447868"/>
-          </a:xfrm>
-          <a:prstGeom prst="rect">
-            <a:avLst/>
-          </a:prstGeom>
-        </p:spPr>
-      </p:pic>
-      <p:pic>
-        <p:nvPicPr>
-          <p:cNvPr id="9" name="Picture 8">
-            <a:extLst>
-              <a:ext uri="{FF2B5EF4-FFF2-40B4-BE49-F238E27FC236}">
-                <a16:creationId xmlns:a16="http://schemas.microsoft.com/office/drawing/2014/main" id="{E06B5D78-5ED7-46DE-97DA-DA9C2C021582}"/>
-              </a:ext>
-            </a:extLst>
-          </p:cNvPr>
-          <p:cNvPicPr>
-            <a:picLocks noChangeAspect="1"/>
-          </p:cNvPicPr>
-          <p:nvPr/>
-        </p:nvPicPr>
-        <p:blipFill>
-          <a:blip r:embed="rId3"/>
-          <a:stretch>
-            <a:fillRect/>
-          </a:stretch>
-        </p:blipFill>
-        <p:spPr>
-          <a:xfrm>
-            <a:off x="8772052" y="2493840"/>
-            <a:ext cx="3419948" cy="3013197"/>
-          </a:xfrm>
-          <a:prstGeom prst="rect">
-            <a:avLst/>
-          </a:prstGeom>
-        </p:spPr>
-      </p:pic>
-      <p:sp>
-        <p:nvSpPr>
-          <p:cNvPr id="10" name="Slide Number Placeholder 9">
-            <a:extLst>
-              <a:ext uri="{FF2B5EF4-FFF2-40B4-BE49-F238E27FC236}">
-                <a16:creationId xmlns:a16="http://schemas.microsoft.com/office/drawing/2014/main" id="{B041DD6A-70F6-4544-BE9E-C30483276E7A}"/>
-              </a:ext>
-            </a:extLst>
-          </p:cNvPr>
-          <p:cNvSpPr>
-            <a:spLocks noGrp="1"/>
-          </p:cNvSpPr>
-          <p:nvPr>
-            <p:ph type="sldNum" sz="quarter" idx="12"/>
-          </p:nvPr>
-        </p:nvSpPr>
-        <p:spPr/>
-        <p:txBody>
-          <a:bodyPr/>
-          <a:lstStyle/>
-          <a:p>
-            <a:fld id="{2BB7EF4A-24AD-40B4-BD2D-14812ACD731E}" type="slidenum">
-              <a:rPr lang="en-US" smtClean="0"/>
-              <a:t>11</a:t>
-            </a:fld>
-            <a:endParaRPr lang="en-US"/>
-          </a:p>
-        </p:txBody>
-      </p:sp>
-      <p:pic>
-        <p:nvPicPr>
-          <p:cNvPr id="8" name="Picture 7">
-            <a:extLst>
-              <a:ext uri="{FF2B5EF4-FFF2-40B4-BE49-F238E27FC236}">
-                <a16:creationId xmlns:a16="http://schemas.microsoft.com/office/drawing/2014/main" id="{F0F925AE-570E-444B-AC83-59BFDE80F362}"/>
-              </a:ext>
-            </a:extLst>
-          </p:cNvPr>
-          <p:cNvPicPr/>
-          <p:nvPr/>
-        </p:nvPicPr>
-        <p:blipFill rotWithShape="1">
-          <a:blip r:embed="rId4" cstate="print">
-            <a:extLst>
-              <a:ext uri="{28A0092B-C50C-407E-A947-70E740481C1C}">
-                <a14:useLocalDpi xmlns:a14="http://schemas.microsoft.com/office/drawing/2010/main" val="0"/>
-              </a:ext>
-            </a:extLst>
-          </a:blip>
-          <a:srcRect l="46864" t="25624" b="49881"/>
-          <a:stretch/>
-        </p:blipFill>
-        <p:spPr bwMode="auto">
-          <a:xfrm>
-            <a:off x="0" y="3010725"/>
-            <a:ext cx="3533775" cy="2496312"/>
-          </a:xfrm>
-          <a:prstGeom prst="rect">
-            <a:avLst/>
-          </a:prstGeom>
-          <a:noFill/>
-          <a:ln>
-            <a:noFill/>
-          </a:ln>
-        </p:spPr>
-      </p:pic>
-    </p:spTree>
-    <p:extLst>
-      <p:ext uri="{BB962C8B-B14F-4D97-AF65-F5344CB8AC3E}">
-        <p14:creationId xmlns:p14="http://schemas.microsoft.com/office/powerpoint/2010/main" val="3030411423"/>
-      </p:ext>
-    </p:extLst>
-  </p:cSld>
-  <p:clrMapOvr>
-    <a:masterClrMapping/>
-  </p:clrMapOvr>
-</p:sld>
-</file>
-
-<file path=ppt/slides/slide12.xml><?xml version="1.0" encoding="utf-8"?>
-<p:sld xmlns:a="http://schemas.openxmlformats.org/drawingml/2006/main" xmlns:r="http://schemas.openxmlformats.org/officeDocument/2006/relationships" xmlns:p="http://schemas.openxmlformats.org/presentationml/2006/main">
-  <p:cSld>
-    <p:spTree>
-      <p:nvGrpSpPr>
-        <p:cNvPr id="1" name=""/>
-        <p:cNvGrpSpPr/>
-        <p:nvPr/>
-      </p:nvGrpSpPr>
-      <p:grpSpPr>
-        <a:xfrm>
-          <a:off x="0" y="0"/>
-          <a:ext cx="0" cy="0"/>
-          <a:chOff x="0" y="0"/>
-          <a:chExt cx="0" cy="0"/>
-        </a:xfrm>
-      </p:grpSpPr>
-      <p:sp>
-        <p:nvSpPr>
-          <p:cNvPr id="4" name="Title 3">
-            <a:extLst>
-              <a:ext uri="{FF2B5EF4-FFF2-40B4-BE49-F238E27FC236}">
                 <a16:creationId xmlns:a16="http://schemas.microsoft.com/office/drawing/2014/main" id="{1C68413C-C38E-462C-B839-0136E5FC851B}"/>
               </a:ext>
             </a:extLst>
@@ -4197,7 +3898,7 @@
           <a:p>
             <a:fld id="{2BB7EF4A-24AD-40B4-BD2D-14812ACD731E}" type="slidenum">
               <a:rPr lang="en-US" smtClean="0"/>
-              <a:t>12</a:t>
+              <a:t>10</a:t>
             </a:fld>
             <a:endParaRPr lang="en-US"/>
           </a:p>
@@ -4283,7 +3984,7 @@
 </p:sld>
 </file>
 
-<file path=ppt/slides/slide13.xml><?xml version="1.0" encoding="utf-8"?>
+<file path=ppt/slides/slide11.xml><?xml version="1.0" encoding="utf-8"?>
 <p:sld xmlns:a="http://schemas.openxmlformats.org/drawingml/2006/main" xmlns:r="http://schemas.openxmlformats.org/officeDocument/2006/relationships" xmlns:p="http://schemas.openxmlformats.org/presentationml/2006/main">
   <p:cSld>
     <p:spTree>
@@ -4354,7 +4055,7 @@
           <a:p>
             <a:fld id="{2BB7EF4A-24AD-40B4-BD2D-14812ACD731E}" type="slidenum">
               <a:rPr lang="en-US" smtClean="0"/>
-              <a:t>13</a:t>
+              <a:t>11</a:t>
             </a:fld>
             <a:endParaRPr lang="en-US"/>
           </a:p>
@@ -4440,7 +4141,7 @@
 </p:sld>
 </file>
 
-<file path=ppt/slides/slide14.xml><?xml version="1.0" encoding="utf-8"?>
+<file path=ppt/slides/slide12.xml><?xml version="1.0" encoding="utf-8"?>
 <p:sld xmlns:a="http://schemas.openxmlformats.org/drawingml/2006/main" xmlns:r="http://schemas.openxmlformats.org/officeDocument/2006/relationships" xmlns:p="http://schemas.openxmlformats.org/presentationml/2006/main">
   <p:cSld>
     <p:spTree>
@@ -4511,7 +4212,7 @@
           <a:p>
             <a:fld id="{2BB7EF4A-24AD-40B4-BD2D-14812ACD731E}" type="slidenum">
               <a:rPr lang="en-US" smtClean="0"/>
-              <a:t>14</a:t>
+              <a:t>12</a:t>
             </a:fld>
             <a:endParaRPr lang="en-US"/>
           </a:p>
@@ -4597,7 +4298,7 @@
 </p:sld>
 </file>
 
-<file path=ppt/slides/slide15.xml><?xml version="1.0" encoding="utf-8"?>
+<file path=ppt/slides/slide13.xml><?xml version="1.0" encoding="utf-8"?>
 <p:sld xmlns:a="http://schemas.openxmlformats.org/drawingml/2006/main" xmlns:r="http://schemas.openxmlformats.org/officeDocument/2006/relationships" xmlns:p="http://schemas.openxmlformats.org/presentationml/2006/main">
   <p:cSld>
     <p:spTree>
@@ -4668,7 +4369,7 @@
           <a:p>
             <a:fld id="{2BB7EF4A-24AD-40B4-BD2D-14812ACD731E}" type="slidenum">
               <a:rPr lang="en-US" smtClean="0"/>
-              <a:t>15</a:t>
+              <a:t>13</a:t>
             </a:fld>
             <a:endParaRPr lang="en-US"/>
           </a:p>
@@ -4754,7 +4455,7 @@
 </p:sld>
 </file>
 
-<file path=ppt/slides/slide16.xml><?xml version="1.0" encoding="utf-8"?>
+<file path=ppt/slides/slide14.xml><?xml version="1.0" encoding="utf-8"?>
 <p:sld xmlns:a="http://schemas.openxmlformats.org/drawingml/2006/main" xmlns:r="http://schemas.openxmlformats.org/officeDocument/2006/relationships" xmlns:p="http://schemas.openxmlformats.org/presentationml/2006/main">
   <p:cSld>
     <p:spTree>
@@ -4825,7 +4526,7 @@
           <a:p>
             <a:fld id="{2BB7EF4A-24AD-40B4-BD2D-14812ACD731E}" type="slidenum">
               <a:rPr lang="en-US" smtClean="0"/>
-              <a:t>16</a:t>
+              <a:t>14</a:t>
             </a:fld>
             <a:endParaRPr lang="en-US"/>
           </a:p>
@@ -4943,6 +4644,402 @@
     <p:extLst>
       <p:ext uri="{BB962C8B-B14F-4D97-AF65-F5344CB8AC3E}">
         <p14:creationId xmlns:p14="http://schemas.microsoft.com/office/powerpoint/2010/main" val="179098315"/>
+      </p:ext>
+    </p:extLst>
+  </p:cSld>
+  <p:clrMapOvr>
+    <a:masterClrMapping/>
+  </p:clrMapOvr>
+</p:sld>
+</file>
+
+<file path=ppt/slides/slide15.xml><?xml version="1.0" encoding="utf-8"?>
+<p:sld xmlns:a="http://schemas.openxmlformats.org/drawingml/2006/main" xmlns:r="http://schemas.openxmlformats.org/officeDocument/2006/relationships" xmlns:p="http://schemas.openxmlformats.org/presentationml/2006/main">
+  <p:cSld>
+    <p:spTree>
+      <p:nvGrpSpPr>
+        <p:cNvPr id="1" name=""/>
+        <p:cNvGrpSpPr/>
+        <p:nvPr/>
+      </p:nvGrpSpPr>
+      <p:grpSpPr>
+        <a:xfrm>
+          <a:off x="0" y="0"/>
+          <a:ext cx="0" cy="0"/>
+          <a:chOff x="0" y="0"/>
+          <a:chExt cx="0" cy="0"/>
+        </a:xfrm>
+      </p:grpSpPr>
+      <p:pic>
+        <p:nvPicPr>
+          <p:cNvPr id="10" name="Picture 9">
+            <a:extLst>
+              <a:ext uri="{FF2B5EF4-FFF2-40B4-BE49-F238E27FC236}">
+                <a16:creationId xmlns:a16="http://schemas.microsoft.com/office/drawing/2014/main" id="{1C10F9F5-BB4A-4F05-A005-505E2699EE92}"/>
+              </a:ext>
+            </a:extLst>
+          </p:cNvPr>
+          <p:cNvPicPr>
+            <a:picLocks noChangeAspect="1"/>
+          </p:cNvPicPr>
+          <p:nvPr/>
+        </p:nvPicPr>
+        <p:blipFill>
+          <a:blip r:embed="rId2"/>
+          <a:stretch>
+            <a:fillRect/>
+          </a:stretch>
+        </p:blipFill>
+        <p:spPr>
+          <a:xfrm>
+            <a:off x="1804241" y="1690688"/>
+            <a:ext cx="8583515" cy="4344655"/>
+          </a:xfrm>
+          <a:prstGeom prst="rect">
+            <a:avLst/>
+          </a:prstGeom>
+        </p:spPr>
+      </p:pic>
+      <p:sp>
+        <p:nvSpPr>
+          <p:cNvPr id="2" name="Title 1">
+            <a:extLst>
+              <a:ext uri="{FF2B5EF4-FFF2-40B4-BE49-F238E27FC236}">
+                <a16:creationId xmlns:a16="http://schemas.microsoft.com/office/drawing/2014/main" id="{37DA52D2-AE8A-4E1C-9811-BBC0D23169DC}"/>
+              </a:ext>
+            </a:extLst>
+          </p:cNvPr>
+          <p:cNvSpPr>
+            <a:spLocks noGrp="1"/>
+          </p:cNvSpPr>
+          <p:nvPr>
+            <p:ph type="title"/>
+          </p:nvPr>
+        </p:nvSpPr>
+        <p:spPr/>
+        <p:txBody>
+          <a:bodyPr/>
+          <a:lstStyle/>
+          <a:p>
+            <a:r>
+              <a:rPr lang="en-US" dirty="0">
+                <a:latin typeface="Times New Roman" panose="02020603050405020304" pitchFamily="18" charset="0"/>
+                <a:cs typeface="Times New Roman" panose="02020603050405020304" pitchFamily="18" charset="0"/>
+              </a:rPr>
+              <a:t>Equation 50</a:t>
+            </a:r>
+          </a:p>
+        </p:txBody>
+      </p:sp>
+      <p:sp>
+        <p:nvSpPr>
+          <p:cNvPr id="3" name="Slide Number Placeholder 2">
+            <a:extLst>
+              <a:ext uri="{FF2B5EF4-FFF2-40B4-BE49-F238E27FC236}">
+                <a16:creationId xmlns:a16="http://schemas.microsoft.com/office/drawing/2014/main" id="{1A6CBFDE-B704-4468-BEA3-2E7EEC07E221}"/>
+              </a:ext>
+            </a:extLst>
+          </p:cNvPr>
+          <p:cNvSpPr>
+            <a:spLocks noGrp="1"/>
+          </p:cNvSpPr>
+          <p:nvPr>
+            <p:ph type="sldNum" sz="quarter" idx="12"/>
+          </p:nvPr>
+        </p:nvSpPr>
+        <p:spPr/>
+        <p:txBody>
+          <a:bodyPr/>
+          <a:lstStyle/>
+          <a:p>
+            <a:fld id="{2BB7EF4A-24AD-40B4-BD2D-14812ACD731E}" type="slidenum">
+              <a:rPr lang="en-US" smtClean="0"/>
+              <a:t>15</a:t>
+            </a:fld>
+            <a:endParaRPr lang="en-US"/>
+          </a:p>
+        </p:txBody>
+      </p:sp>
+      <p:sp>
+        <p:nvSpPr>
+          <p:cNvPr id="6" name="TextBox 5">
+            <a:extLst>
+              <a:ext uri="{FF2B5EF4-FFF2-40B4-BE49-F238E27FC236}">
+                <a16:creationId xmlns:a16="http://schemas.microsoft.com/office/drawing/2014/main" id="{E2410EB0-8226-4512-8283-0814B26F438C}"/>
+              </a:ext>
+            </a:extLst>
+          </p:cNvPr>
+          <p:cNvSpPr txBox="1"/>
+          <p:nvPr/>
+        </p:nvSpPr>
+        <p:spPr>
+          <a:xfrm>
+            <a:off x="2830285" y="2856411"/>
+            <a:ext cx="2290355" cy="1862048"/>
+          </a:xfrm>
+          <a:prstGeom prst="rect">
+            <a:avLst/>
+          </a:prstGeom>
+          <a:noFill/>
+        </p:spPr>
+        <p:txBody>
+          <a:bodyPr wrap="square" rtlCol="0">
+            <a:spAutoFit/>
+          </a:bodyPr>
+          <a:lstStyle/>
+          <a:p>
+            <a:pPr algn="ctr"/>
+            <a:r>
+              <a:rPr lang="en-US" sz="11500" dirty="0">
+                <a:latin typeface="Times New Roman" panose="02020603050405020304" pitchFamily="18" charset="0"/>
+                <a:cs typeface="Times New Roman" panose="02020603050405020304" pitchFamily="18" charset="0"/>
+              </a:rPr>
+              <a:t>-2</a:t>
+            </a:r>
+          </a:p>
+        </p:txBody>
+      </p:sp>
+      <p:sp>
+        <p:nvSpPr>
+          <p:cNvPr id="7" name="TextBox 6">
+            <a:extLst>
+              <a:ext uri="{FF2B5EF4-FFF2-40B4-BE49-F238E27FC236}">
+                <a16:creationId xmlns:a16="http://schemas.microsoft.com/office/drawing/2014/main" id="{6417D2E3-51D8-407A-8683-CC9EC489067B}"/>
+              </a:ext>
+            </a:extLst>
+          </p:cNvPr>
+          <p:cNvSpPr txBox="1"/>
+          <p:nvPr/>
+        </p:nvSpPr>
+        <p:spPr>
+          <a:xfrm>
+            <a:off x="7071360" y="2850788"/>
+            <a:ext cx="2290355" cy="1862048"/>
+          </a:xfrm>
+          <a:prstGeom prst="rect">
+            <a:avLst/>
+          </a:prstGeom>
+          <a:noFill/>
+        </p:spPr>
+        <p:txBody>
+          <a:bodyPr wrap="square" rtlCol="0">
+            <a:spAutoFit/>
+          </a:bodyPr>
+          <a:lstStyle/>
+          <a:p>
+            <a:pPr algn="ctr"/>
+            <a:r>
+              <a:rPr lang="en-US" sz="11500" dirty="0">
+                <a:latin typeface="Times New Roman" panose="02020603050405020304" pitchFamily="18" charset="0"/>
+                <a:cs typeface="Times New Roman" panose="02020603050405020304" pitchFamily="18" charset="0"/>
+              </a:rPr>
+              <a:t>-1</a:t>
+            </a:r>
+          </a:p>
+        </p:txBody>
+      </p:sp>
+    </p:spTree>
+    <p:extLst>
+      <p:ext uri="{BB962C8B-B14F-4D97-AF65-F5344CB8AC3E}">
+        <p14:creationId xmlns:p14="http://schemas.microsoft.com/office/powerpoint/2010/main" val="2729259575"/>
+      </p:ext>
+    </p:extLst>
+  </p:cSld>
+  <p:clrMapOvr>
+    <a:masterClrMapping/>
+  </p:clrMapOvr>
+</p:sld>
+</file>
+
+<file path=ppt/slides/slide16.xml><?xml version="1.0" encoding="utf-8"?>
+<p:sld xmlns:a="http://schemas.openxmlformats.org/drawingml/2006/main" xmlns:r="http://schemas.openxmlformats.org/officeDocument/2006/relationships" xmlns:p="http://schemas.openxmlformats.org/presentationml/2006/main">
+  <p:cSld>
+    <p:spTree>
+      <p:nvGrpSpPr>
+        <p:cNvPr id="1" name=""/>
+        <p:cNvGrpSpPr/>
+        <p:nvPr/>
+      </p:nvGrpSpPr>
+      <p:grpSpPr>
+        <a:xfrm>
+          <a:off x="0" y="0"/>
+          <a:ext cx="0" cy="0"/>
+          <a:chOff x="0" y="0"/>
+          <a:chExt cx="0" cy="0"/>
+        </a:xfrm>
+      </p:grpSpPr>
+      <p:pic>
+        <p:nvPicPr>
+          <p:cNvPr id="5" name="Picture 4">
+            <a:extLst>
+              <a:ext uri="{FF2B5EF4-FFF2-40B4-BE49-F238E27FC236}">
+                <a16:creationId xmlns:a16="http://schemas.microsoft.com/office/drawing/2014/main" id="{7E619330-7391-4C9B-9F5A-1215564DC824}"/>
+              </a:ext>
+            </a:extLst>
+          </p:cNvPr>
+          <p:cNvPicPr>
+            <a:picLocks noChangeAspect="1"/>
+          </p:cNvPicPr>
+          <p:nvPr/>
+        </p:nvPicPr>
+        <p:blipFill>
+          <a:blip r:embed="rId2"/>
+          <a:stretch>
+            <a:fillRect/>
+          </a:stretch>
+        </p:blipFill>
+        <p:spPr>
+          <a:xfrm>
+            <a:off x="1804241" y="1690688"/>
+            <a:ext cx="8583515" cy="4344655"/>
+          </a:xfrm>
+          <a:prstGeom prst="rect">
+            <a:avLst/>
+          </a:prstGeom>
+        </p:spPr>
+      </p:pic>
+      <p:sp>
+        <p:nvSpPr>
+          <p:cNvPr id="2" name="Title 1">
+            <a:extLst>
+              <a:ext uri="{FF2B5EF4-FFF2-40B4-BE49-F238E27FC236}">
+                <a16:creationId xmlns:a16="http://schemas.microsoft.com/office/drawing/2014/main" id="{37DA52D2-AE8A-4E1C-9811-BBC0D23169DC}"/>
+              </a:ext>
+            </a:extLst>
+          </p:cNvPr>
+          <p:cNvSpPr>
+            <a:spLocks noGrp="1"/>
+          </p:cNvSpPr>
+          <p:nvPr>
+            <p:ph type="title"/>
+          </p:nvPr>
+        </p:nvSpPr>
+        <p:spPr/>
+        <p:txBody>
+          <a:bodyPr/>
+          <a:lstStyle/>
+          <a:p>
+            <a:r>
+              <a:rPr lang="en-US" dirty="0">
+                <a:latin typeface="Times New Roman" panose="02020603050405020304" pitchFamily="18" charset="0"/>
+                <a:cs typeface="Times New Roman" panose="02020603050405020304" pitchFamily="18" charset="0"/>
+              </a:rPr>
+              <a:t>Equation 51</a:t>
+            </a:r>
+          </a:p>
+        </p:txBody>
+      </p:sp>
+      <p:sp>
+        <p:nvSpPr>
+          <p:cNvPr id="3" name="Slide Number Placeholder 2">
+            <a:extLst>
+              <a:ext uri="{FF2B5EF4-FFF2-40B4-BE49-F238E27FC236}">
+                <a16:creationId xmlns:a16="http://schemas.microsoft.com/office/drawing/2014/main" id="{1A6CBFDE-B704-4468-BEA3-2E7EEC07E221}"/>
+              </a:ext>
+            </a:extLst>
+          </p:cNvPr>
+          <p:cNvSpPr>
+            <a:spLocks noGrp="1"/>
+          </p:cNvSpPr>
+          <p:nvPr>
+            <p:ph type="sldNum" sz="quarter" idx="12"/>
+          </p:nvPr>
+        </p:nvSpPr>
+        <p:spPr/>
+        <p:txBody>
+          <a:bodyPr/>
+          <a:lstStyle/>
+          <a:p>
+            <a:fld id="{2BB7EF4A-24AD-40B4-BD2D-14812ACD731E}" type="slidenum">
+              <a:rPr lang="en-US" smtClean="0"/>
+              <a:t>16</a:t>
+            </a:fld>
+            <a:endParaRPr lang="en-US"/>
+          </a:p>
+        </p:txBody>
+      </p:sp>
+      <p:sp>
+        <p:nvSpPr>
+          <p:cNvPr id="6" name="TextBox 5">
+            <a:extLst>
+              <a:ext uri="{FF2B5EF4-FFF2-40B4-BE49-F238E27FC236}">
+                <a16:creationId xmlns:a16="http://schemas.microsoft.com/office/drawing/2014/main" id="{E2410EB0-8226-4512-8283-0814B26F438C}"/>
+              </a:ext>
+            </a:extLst>
+          </p:cNvPr>
+          <p:cNvSpPr txBox="1"/>
+          <p:nvPr/>
+        </p:nvSpPr>
+        <p:spPr>
+          <a:xfrm>
+            <a:off x="2830285" y="2856411"/>
+            <a:ext cx="2290355" cy="1862048"/>
+          </a:xfrm>
+          <a:prstGeom prst="rect">
+            <a:avLst/>
+          </a:prstGeom>
+          <a:noFill/>
+        </p:spPr>
+        <p:txBody>
+          <a:bodyPr wrap="square" rtlCol="0">
+            <a:spAutoFit/>
+          </a:bodyPr>
+          <a:lstStyle/>
+          <a:p>
+            <a:pPr algn="ctr"/>
+            <a:r>
+              <a:rPr lang="en-US" sz="11500" dirty="0">
+                <a:latin typeface="Times New Roman" panose="02020603050405020304" pitchFamily="18" charset="0"/>
+                <a:cs typeface="Times New Roman" panose="02020603050405020304" pitchFamily="18" charset="0"/>
+              </a:rPr>
+              <a:t>6</a:t>
+            </a:r>
+          </a:p>
+        </p:txBody>
+      </p:sp>
+      <p:sp>
+        <p:nvSpPr>
+          <p:cNvPr id="7" name="TextBox 6">
+            <a:extLst>
+              <a:ext uri="{FF2B5EF4-FFF2-40B4-BE49-F238E27FC236}">
+                <a16:creationId xmlns:a16="http://schemas.microsoft.com/office/drawing/2014/main" id="{6417D2E3-51D8-407A-8683-CC9EC489067B}"/>
+              </a:ext>
+            </a:extLst>
+          </p:cNvPr>
+          <p:cNvSpPr txBox="1"/>
+          <p:nvPr/>
+        </p:nvSpPr>
+        <p:spPr>
+          <a:xfrm>
+            <a:off x="7071360" y="2850788"/>
+            <a:ext cx="2290355" cy="1862048"/>
+          </a:xfrm>
+          <a:prstGeom prst="rect">
+            <a:avLst/>
+          </a:prstGeom>
+          <a:noFill/>
+        </p:spPr>
+        <p:txBody>
+          <a:bodyPr wrap="square" rtlCol="0">
+            <a:spAutoFit/>
+          </a:bodyPr>
+          <a:lstStyle/>
+          <a:p>
+            <a:pPr algn="ctr"/>
+            <a:r>
+              <a:rPr lang="en-US" sz="11500" dirty="0">
+                <a:latin typeface="Times New Roman" panose="02020603050405020304" pitchFamily="18" charset="0"/>
+                <a:cs typeface="Times New Roman" panose="02020603050405020304" pitchFamily="18" charset="0"/>
+              </a:rPr>
+              <a:t>6</a:t>
+            </a:r>
+          </a:p>
+        </p:txBody>
+      </p:sp>
+    </p:spTree>
+    <p:extLst>
+      <p:ext uri="{BB962C8B-B14F-4D97-AF65-F5344CB8AC3E}">
+        <p14:creationId xmlns:p14="http://schemas.microsoft.com/office/powerpoint/2010/main" val="2289222659"/>
       </p:ext>
     </p:extLst>
   </p:cSld>
@@ -4971,10 +5068,10 @@
       </p:grpSpPr>
       <p:pic>
         <p:nvPicPr>
-          <p:cNvPr id="10" name="Picture 9">
-            <a:extLst>
-              <a:ext uri="{FF2B5EF4-FFF2-40B4-BE49-F238E27FC236}">
-                <a16:creationId xmlns:a16="http://schemas.microsoft.com/office/drawing/2014/main" id="{1C10F9F5-BB4A-4F05-A005-505E2699EE92}"/>
+          <p:cNvPr id="8" name="Picture 7">
+            <a:extLst>
+              <a:ext uri="{FF2B5EF4-FFF2-40B4-BE49-F238E27FC236}">
+                <a16:creationId xmlns:a16="http://schemas.microsoft.com/office/drawing/2014/main" id="{02D91DAA-BD0A-4AC4-B3D0-9C32F84CCA49}"/>
               </a:ext>
             </a:extLst>
           </p:cNvPr>
@@ -4991,8 +5088,8 @@
         </p:blipFill>
         <p:spPr>
           <a:xfrm>
-            <a:off x="1804241" y="1690688"/>
-            <a:ext cx="8583515" cy="4344655"/>
+            <a:off x="1805480" y="1690688"/>
+            <a:ext cx="8581035" cy="4343400"/>
           </a:xfrm>
           <a:prstGeom prst="rect">
             <a:avLst/>
@@ -5025,7 +5122,7 @@
                 <a:latin typeface="Times New Roman" panose="02020603050405020304" pitchFamily="18" charset="0"/>
                 <a:cs typeface="Times New Roman" panose="02020603050405020304" pitchFamily="18" charset="0"/>
               </a:rPr>
-              <a:t>Equation 50</a:t>
+              <a:t>Equation 52</a:t>
             </a:r>
           </a:p>
         </p:txBody>
@@ -5093,7 +5190,7 @@
                 <a:latin typeface="Times New Roman" panose="02020603050405020304" pitchFamily="18" charset="0"/>
                 <a:cs typeface="Times New Roman" panose="02020603050405020304" pitchFamily="18" charset="0"/>
               </a:rPr>
-              <a:t>-2</a:t>
+              <a:t>2</a:t>
             </a:r>
           </a:p>
         </p:txBody>
@@ -5132,7 +5229,7 @@
                 <a:latin typeface="Times New Roman" panose="02020603050405020304" pitchFamily="18" charset="0"/>
                 <a:cs typeface="Times New Roman" panose="02020603050405020304" pitchFamily="18" charset="0"/>
               </a:rPr>
-              <a:t>-1</a:t>
+              <a:t>2</a:t>
             </a:r>
           </a:p>
         </p:txBody>
@@ -5140,7 +5237,7 @@
     </p:spTree>
     <p:extLst>
       <p:ext uri="{BB962C8B-B14F-4D97-AF65-F5344CB8AC3E}">
-        <p14:creationId xmlns:p14="http://schemas.microsoft.com/office/powerpoint/2010/main" val="2729259575"/>
+        <p14:creationId xmlns:p14="http://schemas.microsoft.com/office/powerpoint/2010/main" val="2481767486"/>
       </p:ext>
     </p:extLst>
   </p:cSld>
@@ -5172,7 +5269,7 @@
           <p:cNvPr id="5" name="Picture 4">
             <a:extLst>
               <a:ext uri="{FF2B5EF4-FFF2-40B4-BE49-F238E27FC236}">
-                <a16:creationId xmlns:a16="http://schemas.microsoft.com/office/drawing/2014/main" id="{7E619330-7391-4C9B-9F5A-1215564DC824}"/>
+                <a16:creationId xmlns:a16="http://schemas.microsoft.com/office/drawing/2014/main" id="{AB763F0D-D282-4C8B-B9DD-B5FB821F6DE2}"/>
               </a:ext>
             </a:extLst>
           </p:cNvPr>
@@ -5189,8 +5286,8 @@
         </p:blipFill>
         <p:spPr>
           <a:xfrm>
-            <a:off x="1804241" y="1690688"/>
-            <a:ext cx="8583515" cy="4344655"/>
+            <a:off x="1805480" y="1690688"/>
+            <a:ext cx="8581035" cy="4343400"/>
           </a:xfrm>
           <a:prstGeom prst="rect">
             <a:avLst/>
@@ -5223,7 +5320,7 @@
                 <a:latin typeface="Times New Roman" panose="02020603050405020304" pitchFamily="18" charset="0"/>
                 <a:cs typeface="Times New Roman" panose="02020603050405020304" pitchFamily="18" charset="0"/>
               </a:rPr>
-              <a:t>Equation 51</a:t>
+              <a:t>Equation 53</a:t>
             </a:r>
           </a:p>
         </p:txBody>
@@ -5291,7 +5388,7 @@
                 <a:latin typeface="Times New Roman" panose="02020603050405020304" pitchFamily="18" charset="0"/>
                 <a:cs typeface="Times New Roman" panose="02020603050405020304" pitchFamily="18" charset="0"/>
               </a:rPr>
-              <a:t>6</a:t>
+              <a:t>-7</a:t>
             </a:r>
           </a:p>
         </p:txBody>
@@ -5338,7 +5435,7 @@
     </p:spTree>
     <p:extLst>
       <p:ext uri="{BB962C8B-B14F-4D97-AF65-F5344CB8AC3E}">
-        <p14:creationId xmlns:p14="http://schemas.microsoft.com/office/powerpoint/2010/main" val="2289222659"/>
+        <p14:creationId xmlns:p14="http://schemas.microsoft.com/office/powerpoint/2010/main" val="1880062685"/>
       </p:ext>
     </p:extLst>
   </p:cSld>
@@ -5370,7 +5467,7 @@
           <p:cNvPr id="8" name="Picture 7">
             <a:extLst>
               <a:ext uri="{FF2B5EF4-FFF2-40B4-BE49-F238E27FC236}">
-                <a16:creationId xmlns:a16="http://schemas.microsoft.com/office/drawing/2014/main" id="{02D91DAA-BD0A-4AC4-B3D0-9C32F84CCA49}"/>
+                <a16:creationId xmlns:a16="http://schemas.microsoft.com/office/drawing/2014/main" id="{8DEA3D22-F253-4736-9DA8-D2CE0ADFE2BB}"/>
               </a:ext>
             </a:extLst>
           </p:cNvPr>
@@ -5393,6 +5490,11 @@
           <a:prstGeom prst="rect">
             <a:avLst/>
           </a:prstGeom>
+          <a:ln>
+            <a:solidFill>
+              <a:schemeClr val="tx1"/>
+            </a:solidFill>
+          </a:ln>
         </p:spPr>
       </p:pic>
       <p:sp>
@@ -5421,7 +5523,7 @@
                 <a:latin typeface="Times New Roman" panose="02020603050405020304" pitchFamily="18" charset="0"/>
                 <a:cs typeface="Times New Roman" panose="02020603050405020304" pitchFamily="18" charset="0"/>
               </a:rPr>
-              <a:t>Equation 52</a:t>
+              <a:t>Equation 54</a:t>
             </a:r>
           </a:p>
         </p:txBody>
@@ -5489,7 +5591,7 @@
                 <a:latin typeface="Times New Roman" panose="02020603050405020304" pitchFamily="18" charset="0"/>
                 <a:cs typeface="Times New Roman" panose="02020603050405020304" pitchFamily="18" charset="0"/>
               </a:rPr>
-              <a:t>2</a:t>
+              <a:t>0</a:t>
             </a:r>
           </a:p>
         </p:txBody>
@@ -5528,7 +5630,7 @@
                 <a:latin typeface="Times New Roman" panose="02020603050405020304" pitchFamily="18" charset="0"/>
                 <a:cs typeface="Times New Roman" panose="02020603050405020304" pitchFamily="18" charset="0"/>
               </a:rPr>
-              <a:t>2</a:t>
+              <a:t>0</a:t>
             </a:r>
           </a:p>
         </p:txBody>
@@ -5536,7 +5638,7 @@
     </p:spTree>
     <p:extLst>
       <p:ext uri="{BB962C8B-B14F-4D97-AF65-F5344CB8AC3E}">
-        <p14:creationId xmlns:p14="http://schemas.microsoft.com/office/powerpoint/2010/main" val="2481767486"/>
+        <p14:creationId xmlns:p14="http://schemas.microsoft.com/office/powerpoint/2010/main" val="2216219402"/>
       </p:ext>
     </p:extLst>
   </p:cSld>
@@ -5565,10 +5667,10 @@
       </p:grpSpPr>
       <p:sp>
         <p:nvSpPr>
-          <p:cNvPr id="2" name="Title 1">
-            <a:extLst>
-              <a:ext uri="{FF2B5EF4-FFF2-40B4-BE49-F238E27FC236}">
-                <a16:creationId xmlns:a16="http://schemas.microsoft.com/office/drawing/2014/main" id="{E9A8B7BF-8B8B-4D5A-810B-27282316748B}"/>
+          <p:cNvPr id="7" name="Title 6">
+            <a:extLst>
+              <a:ext uri="{FF2B5EF4-FFF2-40B4-BE49-F238E27FC236}">
+                <a16:creationId xmlns:a16="http://schemas.microsoft.com/office/drawing/2014/main" id="{96C26221-B21C-498C-93E3-BCA9A2A9F228}"/>
               </a:ext>
             </a:extLst>
           </p:cNvPr>
@@ -5584,32 +5686,13 @@
           <a:bodyPr/>
           <a:lstStyle/>
           <a:p>
-            <a:endParaRPr lang="en-US"/>
-          </a:p>
-        </p:txBody>
-      </p:sp>
-      <p:sp>
-        <p:nvSpPr>
-          <p:cNvPr id="3" name="Text Placeholder 2">
-            <a:extLst>
-              <a:ext uri="{FF2B5EF4-FFF2-40B4-BE49-F238E27FC236}">
-                <a16:creationId xmlns:a16="http://schemas.microsoft.com/office/drawing/2014/main" id="{02936A36-563D-47C5-9A46-B3A26D85A402}"/>
-              </a:ext>
-            </a:extLst>
-          </p:cNvPr>
-          <p:cNvSpPr>
-            <a:spLocks noGrp="1"/>
-          </p:cNvSpPr>
-          <p:nvPr>
-            <p:ph type="body" idx="1"/>
-          </p:nvPr>
-        </p:nvSpPr>
-        <p:spPr/>
-        <p:txBody>
-          <a:bodyPr/>
-          <a:lstStyle/>
-          <a:p>
-            <a:endParaRPr lang="en-US"/>
+            <a:r>
+              <a:rPr lang="en-US" dirty="0">
+                <a:latin typeface="Times New Roman" panose="02020603050405020304" pitchFamily="18" charset="0"/>
+                <a:cs typeface="Times New Roman" panose="02020603050405020304" pitchFamily="18" charset="0"/>
+              </a:rPr>
+              <a:t>Equation 49</a:t>
+            </a:r>
           </a:p>
         </p:txBody>
       </p:sp>
@@ -5618,7 +5701,7 @@
           <p:cNvPr id="4" name="Slide Number Placeholder 3">
             <a:extLst>
               <a:ext uri="{FF2B5EF4-FFF2-40B4-BE49-F238E27FC236}">
-                <a16:creationId xmlns:a16="http://schemas.microsoft.com/office/drawing/2014/main" id="{9AA2C77A-7CEC-4EC0-A5BD-F28DB183A70C}"/>
+                <a16:creationId xmlns:a16="http://schemas.microsoft.com/office/drawing/2014/main" id="{110D253D-7A0F-4561-B985-78D4E9A7277F}"/>
               </a:ext>
             </a:extLst>
           </p:cNvPr>
@@ -5642,42 +5725,12 @@
           </a:p>
         </p:txBody>
       </p:sp>
-    </p:spTree>
-    <p:extLst>
-      <p:ext uri="{BB962C8B-B14F-4D97-AF65-F5344CB8AC3E}">
-        <p14:creationId xmlns:p14="http://schemas.microsoft.com/office/powerpoint/2010/main" val="3615953674"/>
-      </p:ext>
-    </p:extLst>
-  </p:cSld>
-  <p:clrMapOvr>
-    <a:masterClrMapping/>
-  </p:clrMapOvr>
-</p:sld>
-</file>
-
-<file path=ppt/slides/slide20.xml><?xml version="1.0" encoding="utf-8"?>
-<p:sld xmlns:a="http://schemas.openxmlformats.org/drawingml/2006/main" xmlns:r="http://schemas.openxmlformats.org/officeDocument/2006/relationships" xmlns:p="http://schemas.openxmlformats.org/presentationml/2006/main">
-  <p:cSld>
-    <p:spTree>
-      <p:nvGrpSpPr>
-        <p:cNvPr id="1" name=""/>
-        <p:cNvGrpSpPr/>
-        <p:nvPr/>
-      </p:nvGrpSpPr>
-      <p:grpSpPr>
-        <a:xfrm>
-          <a:off x="0" y="0"/>
-          <a:ext cx="0" cy="0"/>
-          <a:chOff x="0" y="0"/>
-          <a:chExt cx="0" cy="0"/>
-        </a:xfrm>
-      </p:grpSpPr>
       <p:pic>
         <p:nvPicPr>
-          <p:cNvPr id="5" name="Picture 4">
-            <a:extLst>
-              <a:ext uri="{FF2B5EF4-FFF2-40B4-BE49-F238E27FC236}">
-                <a16:creationId xmlns:a16="http://schemas.microsoft.com/office/drawing/2014/main" id="{AB763F0D-D282-4C8B-B9DD-B5FB821F6DE2}"/>
+          <p:cNvPr id="3" name="Picture 2">
+            <a:extLst>
+              <a:ext uri="{FF2B5EF4-FFF2-40B4-BE49-F238E27FC236}">
+                <a16:creationId xmlns:a16="http://schemas.microsoft.com/office/drawing/2014/main" id="{4033EDA2-221C-4258-AC0A-BCF8731432EF}"/>
               </a:ext>
             </a:extLst>
           </p:cNvPr>
@@ -5687,366 +5740,31 @@
           <p:nvPr/>
         </p:nvPicPr>
         <p:blipFill>
-          <a:blip r:embed="rId2"/>
+          <a:blip r:embed="rId2">
+            <a:extLst>
+              <a:ext uri="{28A0092B-C50C-407E-A947-70E740481C1C}">
+                <a14:useLocalDpi xmlns:a14="http://schemas.microsoft.com/office/drawing/2010/main" val="0"/>
+              </a:ext>
+            </a:extLst>
+          </a:blip>
           <a:stretch>
             <a:fillRect/>
           </a:stretch>
         </p:blipFill>
         <p:spPr>
           <a:xfrm>
-            <a:off x="1805480" y="1690688"/>
-            <a:ext cx="8581035" cy="4343400"/>
+            <a:off x="2894385" y="1246378"/>
+            <a:ext cx="6403230" cy="5554283"/>
           </a:xfrm>
           <a:prstGeom prst="rect">
             <a:avLst/>
           </a:prstGeom>
         </p:spPr>
       </p:pic>
-      <p:sp>
-        <p:nvSpPr>
-          <p:cNvPr id="2" name="Title 1">
-            <a:extLst>
-              <a:ext uri="{FF2B5EF4-FFF2-40B4-BE49-F238E27FC236}">
-                <a16:creationId xmlns:a16="http://schemas.microsoft.com/office/drawing/2014/main" id="{37DA52D2-AE8A-4E1C-9811-BBC0D23169DC}"/>
-              </a:ext>
-            </a:extLst>
-          </p:cNvPr>
-          <p:cNvSpPr>
-            <a:spLocks noGrp="1"/>
-          </p:cNvSpPr>
-          <p:nvPr>
-            <p:ph type="title"/>
-          </p:nvPr>
-        </p:nvSpPr>
-        <p:spPr/>
-        <p:txBody>
-          <a:bodyPr/>
-          <a:lstStyle/>
-          <a:p>
-            <a:r>
-              <a:rPr lang="en-US" dirty="0">
-                <a:latin typeface="Times New Roman" panose="02020603050405020304" pitchFamily="18" charset="0"/>
-                <a:cs typeface="Times New Roman" panose="02020603050405020304" pitchFamily="18" charset="0"/>
-              </a:rPr>
-              <a:t>Equation 53</a:t>
-            </a:r>
-          </a:p>
-        </p:txBody>
-      </p:sp>
-      <p:sp>
-        <p:nvSpPr>
-          <p:cNvPr id="3" name="Slide Number Placeholder 2">
-            <a:extLst>
-              <a:ext uri="{FF2B5EF4-FFF2-40B4-BE49-F238E27FC236}">
-                <a16:creationId xmlns:a16="http://schemas.microsoft.com/office/drawing/2014/main" id="{1A6CBFDE-B704-4468-BEA3-2E7EEC07E221}"/>
-              </a:ext>
-            </a:extLst>
-          </p:cNvPr>
-          <p:cNvSpPr>
-            <a:spLocks noGrp="1"/>
-          </p:cNvSpPr>
-          <p:nvPr>
-            <p:ph type="sldNum" sz="quarter" idx="12"/>
-          </p:nvPr>
-        </p:nvSpPr>
-        <p:spPr/>
-        <p:txBody>
-          <a:bodyPr/>
-          <a:lstStyle/>
-          <a:p>
-            <a:fld id="{2BB7EF4A-24AD-40B4-BD2D-14812ACD731E}" type="slidenum">
-              <a:rPr lang="en-US" smtClean="0"/>
-              <a:t>20</a:t>
-            </a:fld>
-            <a:endParaRPr lang="en-US"/>
-          </a:p>
-        </p:txBody>
-      </p:sp>
-      <p:sp>
-        <p:nvSpPr>
-          <p:cNvPr id="6" name="TextBox 5">
-            <a:extLst>
-              <a:ext uri="{FF2B5EF4-FFF2-40B4-BE49-F238E27FC236}">
-                <a16:creationId xmlns:a16="http://schemas.microsoft.com/office/drawing/2014/main" id="{E2410EB0-8226-4512-8283-0814B26F438C}"/>
-              </a:ext>
-            </a:extLst>
-          </p:cNvPr>
-          <p:cNvSpPr txBox="1"/>
-          <p:nvPr/>
-        </p:nvSpPr>
-        <p:spPr>
-          <a:xfrm>
-            <a:off x="2830285" y="2856411"/>
-            <a:ext cx="2290355" cy="1862048"/>
-          </a:xfrm>
-          <a:prstGeom prst="rect">
-            <a:avLst/>
-          </a:prstGeom>
-          <a:noFill/>
-        </p:spPr>
-        <p:txBody>
-          <a:bodyPr wrap="square" rtlCol="0">
-            <a:spAutoFit/>
-          </a:bodyPr>
-          <a:lstStyle/>
-          <a:p>
-            <a:pPr algn="ctr"/>
-            <a:r>
-              <a:rPr lang="en-US" sz="11500" dirty="0">
-                <a:latin typeface="Times New Roman" panose="02020603050405020304" pitchFamily="18" charset="0"/>
-                <a:cs typeface="Times New Roman" panose="02020603050405020304" pitchFamily="18" charset="0"/>
-              </a:rPr>
-              <a:t>-7</a:t>
-            </a:r>
-          </a:p>
-        </p:txBody>
-      </p:sp>
-      <p:sp>
-        <p:nvSpPr>
-          <p:cNvPr id="7" name="TextBox 6">
-            <a:extLst>
-              <a:ext uri="{FF2B5EF4-FFF2-40B4-BE49-F238E27FC236}">
-                <a16:creationId xmlns:a16="http://schemas.microsoft.com/office/drawing/2014/main" id="{6417D2E3-51D8-407A-8683-CC9EC489067B}"/>
-              </a:ext>
-            </a:extLst>
-          </p:cNvPr>
-          <p:cNvSpPr txBox="1"/>
-          <p:nvPr/>
-        </p:nvSpPr>
-        <p:spPr>
-          <a:xfrm>
-            <a:off x="7071360" y="2850788"/>
-            <a:ext cx="2290355" cy="1862048"/>
-          </a:xfrm>
-          <a:prstGeom prst="rect">
-            <a:avLst/>
-          </a:prstGeom>
-          <a:noFill/>
-        </p:spPr>
-        <p:txBody>
-          <a:bodyPr wrap="square" rtlCol="0">
-            <a:spAutoFit/>
-          </a:bodyPr>
-          <a:lstStyle/>
-          <a:p>
-            <a:pPr algn="ctr"/>
-            <a:r>
-              <a:rPr lang="en-US" sz="11500" dirty="0">
-                <a:latin typeface="Times New Roman" panose="02020603050405020304" pitchFamily="18" charset="0"/>
-                <a:cs typeface="Times New Roman" panose="02020603050405020304" pitchFamily="18" charset="0"/>
-              </a:rPr>
-              <a:t>6</a:t>
-            </a:r>
-          </a:p>
-        </p:txBody>
-      </p:sp>
     </p:spTree>
     <p:extLst>
       <p:ext uri="{BB962C8B-B14F-4D97-AF65-F5344CB8AC3E}">
-        <p14:creationId xmlns:p14="http://schemas.microsoft.com/office/powerpoint/2010/main" val="1880062685"/>
-      </p:ext>
-    </p:extLst>
-  </p:cSld>
-  <p:clrMapOvr>
-    <a:masterClrMapping/>
-  </p:clrMapOvr>
-</p:sld>
-</file>
-
-<file path=ppt/slides/slide21.xml><?xml version="1.0" encoding="utf-8"?>
-<p:sld xmlns:a="http://schemas.openxmlformats.org/drawingml/2006/main" xmlns:r="http://schemas.openxmlformats.org/officeDocument/2006/relationships" xmlns:p="http://schemas.openxmlformats.org/presentationml/2006/main">
-  <p:cSld>
-    <p:spTree>
-      <p:nvGrpSpPr>
-        <p:cNvPr id="1" name=""/>
-        <p:cNvGrpSpPr/>
-        <p:nvPr/>
-      </p:nvGrpSpPr>
-      <p:grpSpPr>
-        <a:xfrm>
-          <a:off x="0" y="0"/>
-          <a:ext cx="0" cy="0"/>
-          <a:chOff x="0" y="0"/>
-          <a:chExt cx="0" cy="0"/>
-        </a:xfrm>
-      </p:grpSpPr>
-      <p:pic>
-        <p:nvPicPr>
-          <p:cNvPr id="8" name="Picture 7">
-            <a:extLst>
-              <a:ext uri="{FF2B5EF4-FFF2-40B4-BE49-F238E27FC236}">
-                <a16:creationId xmlns:a16="http://schemas.microsoft.com/office/drawing/2014/main" id="{8DEA3D22-F253-4736-9DA8-D2CE0ADFE2BB}"/>
-              </a:ext>
-            </a:extLst>
-          </p:cNvPr>
-          <p:cNvPicPr>
-            <a:picLocks noChangeAspect="1"/>
-          </p:cNvPicPr>
-          <p:nvPr/>
-        </p:nvPicPr>
-        <p:blipFill>
-          <a:blip r:embed="rId2"/>
-          <a:stretch>
-            <a:fillRect/>
-          </a:stretch>
-        </p:blipFill>
-        <p:spPr>
-          <a:xfrm>
-            <a:off x="1805480" y="1690688"/>
-            <a:ext cx="8581035" cy="4343400"/>
-          </a:xfrm>
-          <a:prstGeom prst="rect">
-            <a:avLst/>
-          </a:prstGeom>
-          <a:ln>
-            <a:solidFill>
-              <a:schemeClr val="tx1"/>
-            </a:solidFill>
-          </a:ln>
-        </p:spPr>
-      </p:pic>
-      <p:sp>
-        <p:nvSpPr>
-          <p:cNvPr id="2" name="Title 1">
-            <a:extLst>
-              <a:ext uri="{FF2B5EF4-FFF2-40B4-BE49-F238E27FC236}">
-                <a16:creationId xmlns:a16="http://schemas.microsoft.com/office/drawing/2014/main" id="{37DA52D2-AE8A-4E1C-9811-BBC0D23169DC}"/>
-              </a:ext>
-            </a:extLst>
-          </p:cNvPr>
-          <p:cNvSpPr>
-            <a:spLocks noGrp="1"/>
-          </p:cNvSpPr>
-          <p:nvPr>
-            <p:ph type="title"/>
-          </p:nvPr>
-        </p:nvSpPr>
-        <p:spPr/>
-        <p:txBody>
-          <a:bodyPr/>
-          <a:lstStyle/>
-          <a:p>
-            <a:r>
-              <a:rPr lang="en-US" dirty="0">
-                <a:latin typeface="Times New Roman" panose="02020603050405020304" pitchFamily="18" charset="0"/>
-                <a:cs typeface="Times New Roman" panose="02020603050405020304" pitchFamily="18" charset="0"/>
-              </a:rPr>
-              <a:t>Equation 54</a:t>
-            </a:r>
-          </a:p>
-        </p:txBody>
-      </p:sp>
-      <p:sp>
-        <p:nvSpPr>
-          <p:cNvPr id="3" name="Slide Number Placeholder 2">
-            <a:extLst>
-              <a:ext uri="{FF2B5EF4-FFF2-40B4-BE49-F238E27FC236}">
-                <a16:creationId xmlns:a16="http://schemas.microsoft.com/office/drawing/2014/main" id="{1A6CBFDE-B704-4468-BEA3-2E7EEC07E221}"/>
-              </a:ext>
-            </a:extLst>
-          </p:cNvPr>
-          <p:cNvSpPr>
-            <a:spLocks noGrp="1"/>
-          </p:cNvSpPr>
-          <p:nvPr>
-            <p:ph type="sldNum" sz="quarter" idx="12"/>
-          </p:nvPr>
-        </p:nvSpPr>
-        <p:spPr/>
-        <p:txBody>
-          <a:bodyPr/>
-          <a:lstStyle/>
-          <a:p>
-            <a:fld id="{2BB7EF4A-24AD-40B4-BD2D-14812ACD731E}" type="slidenum">
-              <a:rPr lang="en-US" smtClean="0"/>
-              <a:t>21</a:t>
-            </a:fld>
-            <a:endParaRPr lang="en-US"/>
-          </a:p>
-        </p:txBody>
-      </p:sp>
-      <p:sp>
-        <p:nvSpPr>
-          <p:cNvPr id="6" name="TextBox 5">
-            <a:extLst>
-              <a:ext uri="{FF2B5EF4-FFF2-40B4-BE49-F238E27FC236}">
-                <a16:creationId xmlns:a16="http://schemas.microsoft.com/office/drawing/2014/main" id="{E2410EB0-8226-4512-8283-0814B26F438C}"/>
-              </a:ext>
-            </a:extLst>
-          </p:cNvPr>
-          <p:cNvSpPr txBox="1"/>
-          <p:nvPr/>
-        </p:nvSpPr>
-        <p:spPr>
-          <a:xfrm>
-            <a:off x="2830285" y="2856411"/>
-            <a:ext cx="2290355" cy="1862048"/>
-          </a:xfrm>
-          <a:prstGeom prst="rect">
-            <a:avLst/>
-          </a:prstGeom>
-          <a:noFill/>
-        </p:spPr>
-        <p:txBody>
-          <a:bodyPr wrap="square" rtlCol="0">
-            <a:spAutoFit/>
-          </a:bodyPr>
-          <a:lstStyle/>
-          <a:p>
-            <a:pPr algn="ctr"/>
-            <a:r>
-              <a:rPr lang="en-US" sz="11500" dirty="0">
-                <a:latin typeface="Times New Roman" panose="02020603050405020304" pitchFamily="18" charset="0"/>
-                <a:cs typeface="Times New Roman" panose="02020603050405020304" pitchFamily="18" charset="0"/>
-              </a:rPr>
-              <a:t>0</a:t>
-            </a:r>
-          </a:p>
-        </p:txBody>
-      </p:sp>
-      <p:sp>
-        <p:nvSpPr>
-          <p:cNvPr id="7" name="TextBox 6">
-            <a:extLst>
-              <a:ext uri="{FF2B5EF4-FFF2-40B4-BE49-F238E27FC236}">
-                <a16:creationId xmlns:a16="http://schemas.microsoft.com/office/drawing/2014/main" id="{6417D2E3-51D8-407A-8683-CC9EC489067B}"/>
-              </a:ext>
-            </a:extLst>
-          </p:cNvPr>
-          <p:cNvSpPr txBox="1"/>
-          <p:nvPr/>
-        </p:nvSpPr>
-        <p:spPr>
-          <a:xfrm>
-            <a:off x="7071360" y="2850788"/>
-            <a:ext cx="2290355" cy="1862048"/>
-          </a:xfrm>
-          <a:prstGeom prst="rect">
-            <a:avLst/>
-          </a:prstGeom>
-          <a:noFill/>
-        </p:spPr>
-        <p:txBody>
-          <a:bodyPr wrap="square" rtlCol="0">
-            <a:spAutoFit/>
-          </a:bodyPr>
-          <a:lstStyle/>
-          <a:p>
-            <a:pPr algn="ctr"/>
-            <a:r>
-              <a:rPr lang="en-US" sz="11500" dirty="0">
-                <a:latin typeface="Times New Roman" panose="02020603050405020304" pitchFamily="18" charset="0"/>
-                <a:cs typeface="Times New Roman" panose="02020603050405020304" pitchFamily="18" charset="0"/>
-              </a:rPr>
-              <a:t>0</a:t>
-            </a:r>
-          </a:p>
-        </p:txBody>
-      </p:sp>
-    </p:spTree>
-    <p:extLst>
-      <p:ext uri="{BB962C8B-B14F-4D97-AF65-F5344CB8AC3E}">
-        <p14:creationId xmlns:p14="http://schemas.microsoft.com/office/powerpoint/2010/main" val="2216219402"/>
+        <p14:creationId xmlns:p14="http://schemas.microsoft.com/office/powerpoint/2010/main" val="4216648945"/>
       </p:ext>
     </p:extLst>
   </p:cSld>
@@ -6073,12 +5791,72 @@
           <a:chExt cx="0" cy="0"/>
         </a:xfrm>
       </p:grpSpPr>
+      <p:sp>
+        <p:nvSpPr>
+          <p:cNvPr id="7" name="Title 6">
+            <a:extLst>
+              <a:ext uri="{FF2B5EF4-FFF2-40B4-BE49-F238E27FC236}">
+                <a16:creationId xmlns:a16="http://schemas.microsoft.com/office/drawing/2014/main" id="{96C26221-B21C-498C-93E3-BCA9A2A9F228}"/>
+              </a:ext>
+            </a:extLst>
+          </p:cNvPr>
+          <p:cNvSpPr>
+            <a:spLocks noGrp="1"/>
+          </p:cNvSpPr>
+          <p:nvPr>
+            <p:ph type="title"/>
+          </p:nvPr>
+        </p:nvSpPr>
+        <p:spPr/>
+        <p:txBody>
+          <a:bodyPr/>
+          <a:lstStyle/>
+          <a:p>
+            <a:r>
+              <a:rPr lang="en-US" dirty="0">
+                <a:latin typeface="Times New Roman" panose="02020603050405020304" pitchFamily="18" charset="0"/>
+                <a:cs typeface="Times New Roman" panose="02020603050405020304" pitchFamily="18" charset="0"/>
+              </a:rPr>
+              <a:t>Equation 50</a:t>
+            </a:r>
+          </a:p>
+        </p:txBody>
+      </p:sp>
+      <p:sp>
+        <p:nvSpPr>
+          <p:cNvPr id="4" name="Slide Number Placeholder 3">
+            <a:extLst>
+              <a:ext uri="{FF2B5EF4-FFF2-40B4-BE49-F238E27FC236}">
+                <a16:creationId xmlns:a16="http://schemas.microsoft.com/office/drawing/2014/main" id="{110D253D-7A0F-4561-B985-78D4E9A7277F}"/>
+              </a:ext>
+            </a:extLst>
+          </p:cNvPr>
+          <p:cNvSpPr>
+            <a:spLocks noGrp="1"/>
+          </p:cNvSpPr>
+          <p:nvPr>
+            <p:ph type="sldNum" sz="quarter" idx="12"/>
+          </p:nvPr>
+        </p:nvSpPr>
+        <p:spPr/>
+        <p:txBody>
+          <a:bodyPr/>
+          <a:lstStyle/>
+          <a:p>
+            <a:fld id="{2BB7EF4A-24AD-40B4-BD2D-14812ACD731E}" type="slidenum">
+              <a:rPr lang="en-US" smtClean="0"/>
+              <a:t>3</a:t>
+            </a:fld>
+            <a:endParaRPr lang="en-US"/>
+          </a:p>
+        </p:txBody>
+      </p:sp>
       <p:pic>
         <p:nvPicPr>
-          <p:cNvPr id="9" name="Picture 8">
-            <a:extLst>
-              <a:ext uri="{FF2B5EF4-FFF2-40B4-BE49-F238E27FC236}">
-                <a16:creationId xmlns:a16="http://schemas.microsoft.com/office/drawing/2014/main" id="{BC43F648-19B7-46EF-9AF8-87AB13AB2E4B}"/>
+          <p:cNvPr id="8" name="Picture 7">
+            <a:extLst>
+              <a:ext uri="{FF2B5EF4-FFF2-40B4-BE49-F238E27FC236}">
+                <a16:creationId xmlns:a16="http://schemas.microsoft.com/office/drawing/2014/main" id="{4586C4DC-9C2D-4BFC-9635-5331A3FA2BB8}"/>
               </a:ext>
             </a:extLst>
           </p:cNvPr>
@@ -6100,78 +5878,18 @@
         </p:blipFill>
         <p:spPr>
           <a:xfrm>
-            <a:off x="2187533" y="1162735"/>
-            <a:ext cx="8053747" cy="5695264"/>
+            <a:off x="2894385" y="1246378"/>
+            <a:ext cx="6403230" cy="5554282"/>
           </a:xfrm>
           <a:prstGeom prst="rect">
             <a:avLst/>
           </a:prstGeom>
         </p:spPr>
       </p:pic>
-      <p:sp>
-        <p:nvSpPr>
-          <p:cNvPr id="7" name="Title 6">
-            <a:extLst>
-              <a:ext uri="{FF2B5EF4-FFF2-40B4-BE49-F238E27FC236}">
-                <a16:creationId xmlns:a16="http://schemas.microsoft.com/office/drawing/2014/main" id="{96C26221-B21C-498C-93E3-BCA9A2A9F228}"/>
-              </a:ext>
-            </a:extLst>
-          </p:cNvPr>
-          <p:cNvSpPr>
-            <a:spLocks noGrp="1"/>
-          </p:cNvSpPr>
-          <p:nvPr>
-            <p:ph type="title"/>
-          </p:nvPr>
-        </p:nvSpPr>
-        <p:spPr/>
-        <p:txBody>
-          <a:bodyPr/>
-          <a:lstStyle/>
-          <a:p>
-            <a:r>
-              <a:rPr lang="en-US" dirty="0">
-                <a:latin typeface="Times New Roman" panose="02020603050405020304" pitchFamily="18" charset="0"/>
-                <a:cs typeface="Times New Roman" panose="02020603050405020304" pitchFamily="18" charset="0"/>
-              </a:rPr>
-              <a:t>Equation 49</a:t>
-            </a:r>
-          </a:p>
-        </p:txBody>
-      </p:sp>
-      <p:sp>
-        <p:nvSpPr>
-          <p:cNvPr id="4" name="Slide Number Placeholder 3">
-            <a:extLst>
-              <a:ext uri="{FF2B5EF4-FFF2-40B4-BE49-F238E27FC236}">
-                <a16:creationId xmlns:a16="http://schemas.microsoft.com/office/drawing/2014/main" id="{110D253D-7A0F-4561-B985-78D4E9A7277F}"/>
-              </a:ext>
-            </a:extLst>
-          </p:cNvPr>
-          <p:cNvSpPr>
-            <a:spLocks noGrp="1"/>
-          </p:cNvSpPr>
-          <p:nvPr>
-            <p:ph type="sldNum" sz="quarter" idx="12"/>
-          </p:nvPr>
-        </p:nvSpPr>
-        <p:spPr/>
-        <p:txBody>
-          <a:bodyPr/>
-          <a:lstStyle/>
-          <a:p>
-            <a:fld id="{2BB7EF4A-24AD-40B4-BD2D-14812ACD731E}" type="slidenum">
-              <a:rPr lang="en-US" smtClean="0"/>
-              <a:t>3</a:t>
-            </a:fld>
-            <a:endParaRPr lang="en-US"/>
-          </a:p>
-        </p:txBody>
-      </p:sp>
     </p:spTree>
     <p:extLst>
       <p:ext uri="{BB962C8B-B14F-4D97-AF65-F5344CB8AC3E}">
-        <p14:creationId xmlns:p14="http://schemas.microsoft.com/office/powerpoint/2010/main" val="4216648945"/>
+        <p14:creationId xmlns:p14="http://schemas.microsoft.com/office/powerpoint/2010/main" val="1480074329"/>
       </p:ext>
     </p:extLst>
   </p:cSld>
@@ -6198,12 +5916,72 @@
           <a:chExt cx="0" cy="0"/>
         </a:xfrm>
       </p:grpSpPr>
+      <p:sp>
+        <p:nvSpPr>
+          <p:cNvPr id="7" name="Title 6">
+            <a:extLst>
+              <a:ext uri="{FF2B5EF4-FFF2-40B4-BE49-F238E27FC236}">
+                <a16:creationId xmlns:a16="http://schemas.microsoft.com/office/drawing/2014/main" id="{96C26221-B21C-498C-93E3-BCA9A2A9F228}"/>
+              </a:ext>
+            </a:extLst>
+          </p:cNvPr>
+          <p:cNvSpPr>
+            <a:spLocks noGrp="1"/>
+          </p:cNvSpPr>
+          <p:nvPr>
+            <p:ph type="title"/>
+          </p:nvPr>
+        </p:nvSpPr>
+        <p:spPr/>
+        <p:txBody>
+          <a:bodyPr/>
+          <a:lstStyle/>
+          <a:p>
+            <a:r>
+              <a:rPr lang="en-US" dirty="0">
+                <a:latin typeface="Times New Roman" panose="02020603050405020304" pitchFamily="18" charset="0"/>
+                <a:cs typeface="Times New Roman" panose="02020603050405020304" pitchFamily="18" charset="0"/>
+              </a:rPr>
+              <a:t>Equation 51</a:t>
+            </a:r>
+          </a:p>
+        </p:txBody>
+      </p:sp>
+      <p:sp>
+        <p:nvSpPr>
+          <p:cNvPr id="4" name="Slide Number Placeholder 3">
+            <a:extLst>
+              <a:ext uri="{FF2B5EF4-FFF2-40B4-BE49-F238E27FC236}">
+                <a16:creationId xmlns:a16="http://schemas.microsoft.com/office/drawing/2014/main" id="{110D253D-7A0F-4561-B985-78D4E9A7277F}"/>
+              </a:ext>
+            </a:extLst>
+          </p:cNvPr>
+          <p:cNvSpPr>
+            <a:spLocks noGrp="1"/>
+          </p:cNvSpPr>
+          <p:nvPr>
+            <p:ph type="sldNum" sz="quarter" idx="12"/>
+          </p:nvPr>
+        </p:nvSpPr>
+        <p:spPr/>
+        <p:txBody>
+          <a:bodyPr/>
+          <a:lstStyle/>
+          <a:p>
+            <a:fld id="{2BB7EF4A-24AD-40B4-BD2D-14812ACD731E}" type="slidenum">
+              <a:rPr lang="en-US" smtClean="0"/>
+              <a:t>4</a:t>
+            </a:fld>
+            <a:endParaRPr lang="en-US"/>
+          </a:p>
+        </p:txBody>
+      </p:sp>
       <p:pic>
         <p:nvPicPr>
-          <p:cNvPr id="9" name="Picture 8">
-            <a:extLst>
-              <a:ext uri="{FF2B5EF4-FFF2-40B4-BE49-F238E27FC236}">
-                <a16:creationId xmlns:a16="http://schemas.microsoft.com/office/drawing/2014/main" id="{BC43F648-19B7-46EF-9AF8-87AB13AB2E4B}"/>
+          <p:cNvPr id="5" name="Picture 4">
+            <a:extLst>
+              <a:ext uri="{FF2B5EF4-FFF2-40B4-BE49-F238E27FC236}">
+                <a16:creationId xmlns:a16="http://schemas.microsoft.com/office/drawing/2014/main" id="{30A664F5-F1B0-4808-8EBB-A90667143E59}"/>
               </a:ext>
             </a:extLst>
           </p:cNvPr>
@@ -6225,78 +6003,18 @@
         </p:blipFill>
         <p:spPr>
           <a:xfrm>
-            <a:off x="2187533" y="1162735"/>
-            <a:ext cx="8053746" cy="5695264"/>
+            <a:off x="2894385" y="1246378"/>
+            <a:ext cx="6403230" cy="5554282"/>
           </a:xfrm>
           <a:prstGeom prst="rect">
             <a:avLst/>
           </a:prstGeom>
         </p:spPr>
       </p:pic>
-      <p:sp>
-        <p:nvSpPr>
-          <p:cNvPr id="7" name="Title 6">
-            <a:extLst>
-              <a:ext uri="{FF2B5EF4-FFF2-40B4-BE49-F238E27FC236}">
-                <a16:creationId xmlns:a16="http://schemas.microsoft.com/office/drawing/2014/main" id="{96C26221-B21C-498C-93E3-BCA9A2A9F228}"/>
-              </a:ext>
-            </a:extLst>
-          </p:cNvPr>
-          <p:cNvSpPr>
-            <a:spLocks noGrp="1"/>
-          </p:cNvSpPr>
-          <p:nvPr>
-            <p:ph type="title"/>
-          </p:nvPr>
-        </p:nvSpPr>
-        <p:spPr/>
-        <p:txBody>
-          <a:bodyPr/>
-          <a:lstStyle/>
-          <a:p>
-            <a:r>
-              <a:rPr lang="en-US" dirty="0">
-                <a:latin typeface="Times New Roman" panose="02020603050405020304" pitchFamily="18" charset="0"/>
-                <a:cs typeface="Times New Roman" panose="02020603050405020304" pitchFamily="18" charset="0"/>
-              </a:rPr>
-              <a:t>Equation 50</a:t>
-            </a:r>
-          </a:p>
-        </p:txBody>
-      </p:sp>
-      <p:sp>
-        <p:nvSpPr>
-          <p:cNvPr id="4" name="Slide Number Placeholder 3">
-            <a:extLst>
-              <a:ext uri="{FF2B5EF4-FFF2-40B4-BE49-F238E27FC236}">
-                <a16:creationId xmlns:a16="http://schemas.microsoft.com/office/drawing/2014/main" id="{110D253D-7A0F-4561-B985-78D4E9A7277F}"/>
-              </a:ext>
-            </a:extLst>
-          </p:cNvPr>
-          <p:cNvSpPr>
-            <a:spLocks noGrp="1"/>
-          </p:cNvSpPr>
-          <p:nvPr>
-            <p:ph type="sldNum" sz="quarter" idx="12"/>
-          </p:nvPr>
-        </p:nvSpPr>
-        <p:spPr/>
-        <p:txBody>
-          <a:bodyPr/>
-          <a:lstStyle/>
-          <a:p>
-            <a:fld id="{2BB7EF4A-24AD-40B4-BD2D-14812ACD731E}" type="slidenum">
-              <a:rPr lang="en-US" smtClean="0"/>
-              <a:t>4</a:t>
-            </a:fld>
-            <a:endParaRPr lang="en-US"/>
-          </a:p>
-        </p:txBody>
-      </p:sp>
     </p:spTree>
     <p:extLst>
       <p:ext uri="{BB962C8B-B14F-4D97-AF65-F5344CB8AC3E}">
-        <p14:creationId xmlns:p14="http://schemas.microsoft.com/office/powerpoint/2010/main" val="1480074329"/>
+        <p14:creationId xmlns:p14="http://schemas.microsoft.com/office/powerpoint/2010/main" val="1158445341"/>
       </p:ext>
     </p:extLst>
   </p:cSld>
@@ -6349,7 +6067,7 @@
                 <a:latin typeface="Times New Roman" panose="02020603050405020304" pitchFamily="18" charset="0"/>
                 <a:cs typeface="Times New Roman" panose="02020603050405020304" pitchFamily="18" charset="0"/>
               </a:rPr>
-              <a:t>Equation 51</a:t>
+              <a:t>Equation 52</a:t>
             </a:r>
           </a:p>
         </p:txBody>
@@ -6383,10 +6101,45 @@
           </a:p>
         </p:txBody>
       </p:sp>
+      <p:pic>
+        <p:nvPicPr>
+          <p:cNvPr id="5" name="Picture 4">
+            <a:extLst>
+              <a:ext uri="{FF2B5EF4-FFF2-40B4-BE49-F238E27FC236}">
+                <a16:creationId xmlns:a16="http://schemas.microsoft.com/office/drawing/2014/main" id="{6C7C8DCE-2BF0-46A2-A2E8-6A47DB77A010}"/>
+              </a:ext>
+            </a:extLst>
+          </p:cNvPr>
+          <p:cNvPicPr>
+            <a:picLocks noChangeAspect="1"/>
+          </p:cNvPicPr>
+          <p:nvPr/>
+        </p:nvPicPr>
+        <p:blipFill>
+          <a:blip r:embed="rId2">
+            <a:extLst>
+              <a:ext uri="{28A0092B-C50C-407E-A947-70E740481C1C}">
+                <a14:useLocalDpi xmlns:a14="http://schemas.microsoft.com/office/drawing/2010/main" val="0"/>
+              </a:ext>
+            </a:extLst>
+          </a:blip>
+          <a:srcRect/>
+          <a:stretch/>
+        </p:blipFill>
+        <p:spPr>
+          <a:xfrm>
+            <a:off x="2894386" y="1246378"/>
+            <a:ext cx="6403228" cy="5554282"/>
+          </a:xfrm>
+          <a:prstGeom prst="rect">
+            <a:avLst/>
+          </a:prstGeom>
+        </p:spPr>
+      </p:pic>
     </p:spTree>
     <p:extLst>
       <p:ext uri="{BB962C8B-B14F-4D97-AF65-F5344CB8AC3E}">
-        <p14:creationId xmlns:p14="http://schemas.microsoft.com/office/powerpoint/2010/main" val="1158445341"/>
+        <p14:creationId xmlns:p14="http://schemas.microsoft.com/office/powerpoint/2010/main" val="345733914"/>
       </p:ext>
     </p:extLst>
   </p:cSld>
@@ -6413,12 +6166,72 @@
           <a:chExt cx="0" cy="0"/>
         </a:xfrm>
       </p:grpSpPr>
+      <p:sp>
+        <p:nvSpPr>
+          <p:cNvPr id="7" name="Title 6">
+            <a:extLst>
+              <a:ext uri="{FF2B5EF4-FFF2-40B4-BE49-F238E27FC236}">
+                <a16:creationId xmlns:a16="http://schemas.microsoft.com/office/drawing/2014/main" id="{96C26221-B21C-498C-93E3-BCA9A2A9F228}"/>
+              </a:ext>
+            </a:extLst>
+          </p:cNvPr>
+          <p:cNvSpPr>
+            <a:spLocks noGrp="1"/>
+          </p:cNvSpPr>
+          <p:nvPr>
+            <p:ph type="title"/>
+          </p:nvPr>
+        </p:nvSpPr>
+        <p:spPr/>
+        <p:txBody>
+          <a:bodyPr/>
+          <a:lstStyle/>
+          <a:p>
+            <a:r>
+              <a:rPr lang="en-US" dirty="0">
+                <a:latin typeface="Times New Roman" panose="02020603050405020304" pitchFamily="18" charset="0"/>
+                <a:cs typeface="Times New Roman" panose="02020603050405020304" pitchFamily="18" charset="0"/>
+              </a:rPr>
+              <a:t>Equation 53</a:t>
+            </a:r>
+          </a:p>
+        </p:txBody>
+      </p:sp>
+      <p:sp>
+        <p:nvSpPr>
+          <p:cNvPr id="4" name="Slide Number Placeholder 3">
+            <a:extLst>
+              <a:ext uri="{FF2B5EF4-FFF2-40B4-BE49-F238E27FC236}">
+                <a16:creationId xmlns:a16="http://schemas.microsoft.com/office/drawing/2014/main" id="{110D253D-7A0F-4561-B985-78D4E9A7277F}"/>
+              </a:ext>
+            </a:extLst>
+          </p:cNvPr>
+          <p:cNvSpPr>
+            <a:spLocks noGrp="1"/>
+          </p:cNvSpPr>
+          <p:nvPr>
+            <p:ph type="sldNum" sz="quarter" idx="12"/>
+          </p:nvPr>
+        </p:nvSpPr>
+        <p:spPr/>
+        <p:txBody>
+          <a:bodyPr/>
+          <a:lstStyle/>
+          <a:p>
+            <a:fld id="{2BB7EF4A-24AD-40B4-BD2D-14812ACD731E}" type="slidenum">
+              <a:rPr lang="en-US" smtClean="0"/>
+              <a:t>6</a:t>
+            </a:fld>
+            <a:endParaRPr lang="en-US"/>
+          </a:p>
+        </p:txBody>
+      </p:sp>
       <p:pic>
         <p:nvPicPr>
-          <p:cNvPr id="9" name="Picture 8">
-            <a:extLst>
-              <a:ext uri="{FF2B5EF4-FFF2-40B4-BE49-F238E27FC236}">
-                <a16:creationId xmlns:a16="http://schemas.microsoft.com/office/drawing/2014/main" id="{BC43F648-19B7-46EF-9AF8-87AB13AB2E4B}"/>
+          <p:cNvPr id="5" name="Picture 4">
+            <a:extLst>
+              <a:ext uri="{FF2B5EF4-FFF2-40B4-BE49-F238E27FC236}">
+                <a16:creationId xmlns:a16="http://schemas.microsoft.com/office/drawing/2014/main" id="{F75B51CE-BCE5-422A-A29F-249FDF895E58}"/>
               </a:ext>
             </a:extLst>
           </p:cNvPr>
@@ -6440,78 +6253,18 @@
         </p:blipFill>
         <p:spPr>
           <a:xfrm>
-            <a:off x="2187533" y="1162735"/>
-            <a:ext cx="8053746" cy="5695263"/>
+            <a:off x="2894386" y="1246378"/>
+            <a:ext cx="6403228" cy="5554281"/>
           </a:xfrm>
           <a:prstGeom prst="rect">
             <a:avLst/>
           </a:prstGeom>
         </p:spPr>
       </p:pic>
-      <p:sp>
-        <p:nvSpPr>
-          <p:cNvPr id="7" name="Title 6">
-            <a:extLst>
-              <a:ext uri="{FF2B5EF4-FFF2-40B4-BE49-F238E27FC236}">
-                <a16:creationId xmlns:a16="http://schemas.microsoft.com/office/drawing/2014/main" id="{96C26221-B21C-498C-93E3-BCA9A2A9F228}"/>
-              </a:ext>
-            </a:extLst>
-          </p:cNvPr>
-          <p:cNvSpPr>
-            <a:spLocks noGrp="1"/>
-          </p:cNvSpPr>
-          <p:nvPr>
-            <p:ph type="title"/>
-          </p:nvPr>
-        </p:nvSpPr>
-        <p:spPr/>
-        <p:txBody>
-          <a:bodyPr/>
-          <a:lstStyle/>
-          <a:p>
-            <a:r>
-              <a:rPr lang="en-US" dirty="0">
-                <a:latin typeface="Times New Roman" panose="02020603050405020304" pitchFamily="18" charset="0"/>
-                <a:cs typeface="Times New Roman" panose="02020603050405020304" pitchFamily="18" charset="0"/>
-              </a:rPr>
-              <a:t>Equation 52</a:t>
-            </a:r>
-          </a:p>
-        </p:txBody>
-      </p:sp>
-      <p:sp>
-        <p:nvSpPr>
-          <p:cNvPr id="4" name="Slide Number Placeholder 3">
-            <a:extLst>
-              <a:ext uri="{FF2B5EF4-FFF2-40B4-BE49-F238E27FC236}">
-                <a16:creationId xmlns:a16="http://schemas.microsoft.com/office/drawing/2014/main" id="{110D253D-7A0F-4561-B985-78D4E9A7277F}"/>
-              </a:ext>
-            </a:extLst>
-          </p:cNvPr>
-          <p:cNvSpPr>
-            <a:spLocks noGrp="1"/>
-          </p:cNvSpPr>
-          <p:nvPr>
-            <p:ph type="sldNum" sz="quarter" idx="12"/>
-          </p:nvPr>
-        </p:nvSpPr>
-        <p:spPr/>
-        <p:txBody>
-          <a:bodyPr/>
-          <a:lstStyle/>
-          <a:p>
-            <a:fld id="{2BB7EF4A-24AD-40B4-BD2D-14812ACD731E}" type="slidenum">
-              <a:rPr lang="en-US" smtClean="0"/>
-              <a:t>6</a:t>
-            </a:fld>
-            <a:endParaRPr lang="en-US"/>
-          </a:p>
-        </p:txBody>
-      </p:sp>
     </p:spTree>
     <p:extLst>
       <p:ext uri="{BB962C8B-B14F-4D97-AF65-F5344CB8AC3E}">
-        <p14:creationId xmlns:p14="http://schemas.microsoft.com/office/powerpoint/2010/main" val="345733914"/>
+        <p14:creationId xmlns:p14="http://schemas.microsoft.com/office/powerpoint/2010/main" val="2094404979"/>
       </p:ext>
     </p:extLst>
   </p:cSld>
@@ -6538,12 +6291,72 @@
           <a:chExt cx="0" cy="0"/>
         </a:xfrm>
       </p:grpSpPr>
+      <p:sp>
+        <p:nvSpPr>
+          <p:cNvPr id="7" name="Title 6">
+            <a:extLst>
+              <a:ext uri="{FF2B5EF4-FFF2-40B4-BE49-F238E27FC236}">
+                <a16:creationId xmlns:a16="http://schemas.microsoft.com/office/drawing/2014/main" id="{96C26221-B21C-498C-93E3-BCA9A2A9F228}"/>
+              </a:ext>
+            </a:extLst>
+          </p:cNvPr>
+          <p:cNvSpPr>
+            <a:spLocks noGrp="1"/>
+          </p:cNvSpPr>
+          <p:nvPr>
+            <p:ph type="title"/>
+          </p:nvPr>
+        </p:nvSpPr>
+        <p:spPr/>
+        <p:txBody>
+          <a:bodyPr/>
+          <a:lstStyle/>
+          <a:p>
+            <a:r>
+              <a:rPr lang="en-US" dirty="0">
+                <a:latin typeface="Times New Roman" panose="02020603050405020304" pitchFamily="18" charset="0"/>
+                <a:cs typeface="Times New Roman" panose="02020603050405020304" pitchFamily="18" charset="0"/>
+              </a:rPr>
+              <a:t>Equation 54</a:t>
+            </a:r>
+          </a:p>
+        </p:txBody>
+      </p:sp>
+      <p:sp>
+        <p:nvSpPr>
+          <p:cNvPr id="4" name="Slide Number Placeholder 3">
+            <a:extLst>
+              <a:ext uri="{FF2B5EF4-FFF2-40B4-BE49-F238E27FC236}">
+                <a16:creationId xmlns:a16="http://schemas.microsoft.com/office/drawing/2014/main" id="{110D253D-7A0F-4561-B985-78D4E9A7277F}"/>
+              </a:ext>
+            </a:extLst>
+          </p:cNvPr>
+          <p:cNvSpPr>
+            <a:spLocks noGrp="1"/>
+          </p:cNvSpPr>
+          <p:nvPr>
+            <p:ph type="sldNum" sz="quarter" idx="12"/>
+          </p:nvPr>
+        </p:nvSpPr>
+        <p:spPr/>
+        <p:txBody>
+          <a:bodyPr/>
+          <a:lstStyle/>
+          <a:p>
+            <a:fld id="{2BB7EF4A-24AD-40B4-BD2D-14812ACD731E}" type="slidenum">
+              <a:rPr lang="en-US" smtClean="0"/>
+              <a:t>7</a:t>
+            </a:fld>
+            <a:endParaRPr lang="en-US"/>
+          </a:p>
+        </p:txBody>
+      </p:sp>
       <p:pic>
         <p:nvPicPr>
-          <p:cNvPr id="9" name="Picture 8">
-            <a:extLst>
-              <a:ext uri="{FF2B5EF4-FFF2-40B4-BE49-F238E27FC236}">
-                <a16:creationId xmlns:a16="http://schemas.microsoft.com/office/drawing/2014/main" id="{BC43F648-19B7-46EF-9AF8-87AB13AB2E4B}"/>
+          <p:cNvPr id="5" name="Picture 4">
+            <a:extLst>
+              <a:ext uri="{FF2B5EF4-FFF2-40B4-BE49-F238E27FC236}">
+                <a16:creationId xmlns:a16="http://schemas.microsoft.com/office/drawing/2014/main" id="{2AFEBB3C-1609-4D57-B61D-6C409C6E4D93}"/>
               </a:ext>
             </a:extLst>
           </p:cNvPr>
@@ -6565,78 +6378,18 @@
         </p:blipFill>
         <p:spPr>
           <a:xfrm>
-            <a:off x="2187534" y="1162735"/>
-            <a:ext cx="8053744" cy="5695263"/>
+            <a:off x="2894386" y="1246378"/>
+            <a:ext cx="6403228" cy="5554281"/>
           </a:xfrm>
           <a:prstGeom prst="rect">
             <a:avLst/>
           </a:prstGeom>
         </p:spPr>
       </p:pic>
-      <p:sp>
-        <p:nvSpPr>
-          <p:cNvPr id="7" name="Title 6">
-            <a:extLst>
-              <a:ext uri="{FF2B5EF4-FFF2-40B4-BE49-F238E27FC236}">
-                <a16:creationId xmlns:a16="http://schemas.microsoft.com/office/drawing/2014/main" id="{96C26221-B21C-498C-93E3-BCA9A2A9F228}"/>
-              </a:ext>
-            </a:extLst>
-          </p:cNvPr>
-          <p:cNvSpPr>
-            <a:spLocks noGrp="1"/>
-          </p:cNvSpPr>
-          <p:nvPr>
-            <p:ph type="title"/>
-          </p:nvPr>
-        </p:nvSpPr>
-        <p:spPr/>
-        <p:txBody>
-          <a:bodyPr/>
-          <a:lstStyle/>
-          <a:p>
-            <a:r>
-              <a:rPr lang="en-US" dirty="0">
-                <a:latin typeface="Times New Roman" panose="02020603050405020304" pitchFamily="18" charset="0"/>
-                <a:cs typeface="Times New Roman" panose="02020603050405020304" pitchFamily="18" charset="0"/>
-              </a:rPr>
-              <a:t>Equation 53</a:t>
-            </a:r>
-          </a:p>
-        </p:txBody>
-      </p:sp>
-      <p:sp>
-        <p:nvSpPr>
-          <p:cNvPr id="4" name="Slide Number Placeholder 3">
-            <a:extLst>
-              <a:ext uri="{FF2B5EF4-FFF2-40B4-BE49-F238E27FC236}">
-                <a16:creationId xmlns:a16="http://schemas.microsoft.com/office/drawing/2014/main" id="{110D253D-7A0F-4561-B985-78D4E9A7277F}"/>
-              </a:ext>
-            </a:extLst>
-          </p:cNvPr>
-          <p:cNvSpPr>
-            <a:spLocks noGrp="1"/>
-          </p:cNvSpPr>
-          <p:nvPr>
-            <p:ph type="sldNum" sz="quarter" idx="12"/>
-          </p:nvPr>
-        </p:nvSpPr>
-        <p:spPr/>
-        <p:txBody>
-          <a:bodyPr/>
-          <a:lstStyle/>
-          <a:p>
-            <a:fld id="{2BB7EF4A-24AD-40B4-BD2D-14812ACD731E}" type="slidenum">
-              <a:rPr lang="en-US" smtClean="0"/>
-              <a:t>7</a:t>
-            </a:fld>
-            <a:endParaRPr lang="en-US"/>
-          </a:p>
-        </p:txBody>
-      </p:sp>
     </p:spTree>
     <p:extLst>
       <p:ext uri="{BB962C8B-B14F-4D97-AF65-F5344CB8AC3E}">
-        <p14:creationId xmlns:p14="http://schemas.microsoft.com/office/powerpoint/2010/main" val="2094404979"/>
+        <p14:creationId xmlns:p14="http://schemas.microsoft.com/office/powerpoint/2010/main" val="657203541"/>
       </p:ext>
     </p:extLst>
   </p:cSld>
@@ -6665,10 +6418,10 @@
       </p:grpSpPr>
       <p:sp>
         <p:nvSpPr>
-          <p:cNvPr id="7" name="Title 6">
-            <a:extLst>
-              <a:ext uri="{FF2B5EF4-FFF2-40B4-BE49-F238E27FC236}">
-                <a16:creationId xmlns:a16="http://schemas.microsoft.com/office/drawing/2014/main" id="{96C26221-B21C-498C-93E3-BCA9A2A9F228}"/>
+          <p:cNvPr id="4" name="Title 3">
+            <a:extLst>
+              <a:ext uri="{FF2B5EF4-FFF2-40B4-BE49-F238E27FC236}">
+                <a16:creationId xmlns:a16="http://schemas.microsoft.com/office/drawing/2014/main" id="{2A70CDE9-EA15-4B71-94FB-6A4F4E1C4255}"/>
               </a:ext>
             </a:extLst>
           </p:cNvPr>
@@ -6689,17 +6442,42 @@
                 <a:latin typeface="Times New Roman" panose="02020603050405020304" pitchFamily="18" charset="0"/>
                 <a:cs typeface="Times New Roman" panose="02020603050405020304" pitchFamily="18" charset="0"/>
               </a:rPr>
-              <a:t>Equation 54</a:t>
-            </a:r>
-          </a:p>
-        </p:txBody>
-      </p:sp>
-      <p:sp>
-        <p:nvSpPr>
-          <p:cNvPr id="4" name="Slide Number Placeholder 3">
-            <a:extLst>
-              <a:ext uri="{FF2B5EF4-FFF2-40B4-BE49-F238E27FC236}">
-                <a16:creationId xmlns:a16="http://schemas.microsoft.com/office/drawing/2014/main" id="{110D253D-7A0F-4561-B985-78D4E9A7277F}"/>
+              <a:t>Toy data</a:t>
+            </a:r>
+          </a:p>
+        </p:txBody>
+      </p:sp>
+      <p:sp>
+        <p:nvSpPr>
+          <p:cNvPr id="5" name="Text Placeholder 4">
+            <a:extLst>
+              <a:ext uri="{FF2B5EF4-FFF2-40B4-BE49-F238E27FC236}">
+                <a16:creationId xmlns:a16="http://schemas.microsoft.com/office/drawing/2014/main" id="{FF2B6C68-14CF-4FB7-8173-9989FBC807A8}"/>
+              </a:ext>
+            </a:extLst>
+          </p:cNvPr>
+          <p:cNvSpPr>
+            <a:spLocks noGrp="1"/>
+          </p:cNvSpPr>
+          <p:nvPr>
+            <p:ph type="body" idx="1"/>
+          </p:nvPr>
+        </p:nvSpPr>
+        <p:spPr/>
+        <p:txBody>
+          <a:bodyPr/>
+          <a:lstStyle/>
+          <a:p>
+            <a:endParaRPr lang="en-US"/>
+          </a:p>
+        </p:txBody>
+      </p:sp>
+      <p:sp>
+        <p:nvSpPr>
+          <p:cNvPr id="6" name="Slide Number Placeholder 5">
+            <a:extLst>
+              <a:ext uri="{FF2B5EF4-FFF2-40B4-BE49-F238E27FC236}">
+                <a16:creationId xmlns:a16="http://schemas.microsoft.com/office/drawing/2014/main" id="{B958B965-FF81-48C5-84FB-E00D7D4E3B53}"/>
               </a:ext>
             </a:extLst>
           </p:cNvPr>
@@ -6726,7 +6504,7 @@
     </p:spTree>
     <p:extLst>
       <p:ext uri="{BB962C8B-B14F-4D97-AF65-F5344CB8AC3E}">
-        <p14:creationId xmlns:p14="http://schemas.microsoft.com/office/powerpoint/2010/main" val="657203541"/>
+        <p14:creationId xmlns:p14="http://schemas.microsoft.com/office/powerpoint/2010/main" val="125500990"/>
       </p:ext>
     </p:extLst>
   </p:cSld>
@@ -6758,7 +6536,7 @@
           <p:cNvPr id="4" name="Title 3">
             <a:extLst>
               <a:ext uri="{FF2B5EF4-FFF2-40B4-BE49-F238E27FC236}">
-                <a16:creationId xmlns:a16="http://schemas.microsoft.com/office/drawing/2014/main" id="{D2C040E5-A490-4A7E-8FCD-565D94AE9A36}"/>
+                <a16:creationId xmlns:a16="http://schemas.microsoft.com/office/drawing/2014/main" id="{1C68413C-C38E-462C-B839-0136E5FC851B}"/>
               </a:ext>
             </a:extLst>
           </p:cNvPr>
@@ -6779,74 +6557,77 @@
                 <a:latin typeface="Times New Roman" panose="02020603050405020304" pitchFamily="18" charset="0"/>
                 <a:cs typeface="Times New Roman" panose="02020603050405020304" pitchFamily="18" charset="0"/>
               </a:rPr>
-              <a:t>PIE data</a:t>
-            </a:r>
-          </a:p>
-        </p:txBody>
-      </p:sp>
-      <p:sp>
-        <p:nvSpPr>
-          <p:cNvPr id="5" name="Text Placeholder 4">
-            <a:extLst>
-              <a:ext uri="{FF2B5EF4-FFF2-40B4-BE49-F238E27FC236}">
-                <a16:creationId xmlns:a16="http://schemas.microsoft.com/office/drawing/2014/main" id="{6963AE17-2DF9-4348-AF2E-6B069E5C523B}"/>
-              </a:ext>
-            </a:extLst>
-          </p:cNvPr>
-          <p:cNvSpPr>
-            <a:spLocks noGrp="1"/>
-          </p:cNvSpPr>
-          <p:nvPr>
-            <p:ph type="body" idx="1"/>
-          </p:nvPr>
-        </p:nvSpPr>
-        <p:spPr/>
-        <p:txBody>
-          <a:bodyPr/>
-          <a:lstStyle/>
-          <a:p>
-            <a:r>
-              <a:rPr lang="en-US" dirty="0">
-                <a:latin typeface="Times New Roman" panose="02020603050405020304" pitchFamily="18" charset="0"/>
-                <a:cs typeface="Times New Roman" panose="02020603050405020304" pitchFamily="18" charset="0"/>
-              </a:rPr>
-              <a:t>Zoom 2.</a:t>
-            </a:r>
-            <a:br>
-              <a:rPr lang="en-US" dirty="0">
-                <a:latin typeface="Times New Roman" panose="02020603050405020304" pitchFamily="18" charset="0"/>
-                <a:cs typeface="Times New Roman" panose="02020603050405020304" pitchFamily="18" charset="0"/>
-              </a:rPr>
-            </a:br>
-            <a:r>
-              <a:rPr lang="en-US" dirty="0">
-                <a:latin typeface="Times New Roman" panose="02020603050405020304" pitchFamily="18" charset="0"/>
-                <a:cs typeface="Times New Roman" panose="02020603050405020304" pitchFamily="18" charset="0"/>
-              </a:rPr>
-              <a:t>Raster results were made using the code.</a:t>
-            </a:r>
-            <a:br>
-              <a:rPr lang="en-US" dirty="0">
-                <a:latin typeface="Times New Roman" panose="02020603050405020304" pitchFamily="18" charset="0"/>
-                <a:cs typeface="Times New Roman" panose="02020603050405020304" pitchFamily="18" charset="0"/>
-              </a:rPr>
-            </a:br>
-            <a:r>
-              <a:rPr lang="en-US" dirty="0">
-                <a:latin typeface="Times New Roman" panose="02020603050405020304" pitchFamily="18" charset="0"/>
-                <a:cs typeface="Times New Roman" panose="02020603050405020304" pitchFamily="18" charset="0"/>
-              </a:rPr>
-              <a:t>Maps were made using QGIS.</a:t>
-            </a:r>
-          </a:p>
-        </p:txBody>
-      </p:sp>
-      <p:sp>
-        <p:nvSpPr>
-          <p:cNvPr id="3" name="Slide Number Placeholder 2">
-            <a:extLst>
-              <a:ext uri="{FF2B5EF4-FFF2-40B4-BE49-F238E27FC236}">
-                <a16:creationId xmlns:a16="http://schemas.microsoft.com/office/drawing/2014/main" id="{351F9749-A2C9-46C0-9357-CF910109C93F}"/>
+              <a:t>Presence and Sum</a:t>
+            </a:r>
+          </a:p>
+        </p:txBody>
+      </p:sp>
+      <p:pic>
+        <p:nvPicPr>
+          <p:cNvPr id="7" name="Picture 6">
+            <a:extLst>
+              <a:ext uri="{FF2B5EF4-FFF2-40B4-BE49-F238E27FC236}">
+                <a16:creationId xmlns:a16="http://schemas.microsoft.com/office/drawing/2014/main" id="{C7CA9375-DFE4-438F-9115-501A20F14872}"/>
+              </a:ext>
+            </a:extLst>
+          </p:cNvPr>
+          <p:cNvPicPr>
+            <a:picLocks noChangeAspect="1"/>
+          </p:cNvPicPr>
+          <p:nvPr/>
+        </p:nvPicPr>
+        <p:blipFill>
+          <a:blip r:embed="rId2"/>
+          <a:stretch>
+            <a:fillRect/>
+          </a:stretch>
+        </p:blipFill>
+        <p:spPr>
+          <a:xfrm>
+            <a:off x="3535473" y="3034947"/>
+            <a:ext cx="5236579" cy="2447868"/>
+          </a:xfrm>
+          <a:prstGeom prst="rect">
+            <a:avLst/>
+          </a:prstGeom>
+        </p:spPr>
+      </p:pic>
+      <p:pic>
+        <p:nvPicPr>
+          <p:cNvPr id="9" name="Picture 8">
+            <a:extLst>
+              <a:ext uri="{FF2B5EF4-FFF2-40B4-BE49-F238E27FC236}">
+                <a16:creationId xmlns:a16="http://schemas.microsoft.com/office/drawing/2014/main" id="{E06B5D78-5ED7-46DE-97DA-DA9C2C021582}"/>
+              </a:ext>
+            </a:extLst>
+          </p:cNvPr>
+          <p:cNvPicPr>
+            <a:picLocks noChangeAspect="1"/>
+          </p:cNvPicPr>
+          <p:nvPr/>
+        </p:nvPicPr>
+        <p:blipFill>
+          <a:blip r:embed="rId3"/>
+          <a:stretch>
+            <a:fillRect/>
+          </a:stretch>
+        </p:blipFill>
+        <p:spPr>
+          <a:xfrm>
+            <a:off x="8772052" y="2493840"/>
+            <a:ext cx="3419948" cy="3013197"/>
+          </a:xfrm>
+          <a:prstGeom prst="rect">
+            <a:avLst/>
+          </a:prstGeom>
+        </p:spPr>
+      </p:pic>
+      <p:sp>
+        <p:nvSpPr>
+          <p:cNvPr id="10" name="Slide Number Placeholder 9">
+            <a:extLst>
+              <a:ext uri="{FF2B5EF4-FFF2-40B4-BE49-F238E27FC236}">
+                <a16:creationId xmlns:a16="http://schemas.microsoft.com/office/drawing/2014/main" id="{B041DD6A-70F6-4544-BE9E-C30483276E7A}"/>
               </a:ext>
             </a:extLst>
           </p:cNvPr>
@@ -6870,10 +6651,47 @@
           </a:p>
         </p:txBody>
       </p:sp>
+      <p:pic>
+        <p:nvPicPr>
+          <p:cNvPr id="8" name="Picture 7">
+            <a:extLst>
+              <a:ext uri="{FF2B5EF4-FFF2-40B4-BE49-F238E27FC236}">
+                <a16:creationId xmlns:a16="http://schemas.microsoft.com/office/drawing/2014/main" id="{F0F925AE-570E-444B-AC83-59BFDE80F362}"/>
+              </a:ext>
+            </a:extLst>
+          </p:cNvPr>
+          <p:cNvPicPr/>
+          <p:nvPr/>
+        </p:nvPicPr>
+        <p:blipFill rotWithShape="1">
+          <a:blip r:embed="rId4" cstate="print">
+            <a:extLst>
+              <a:ext uri="{28A0092B-C50C-407E-A947-70E740481C1C}">
+                <a14:useLocalDpi xmlns:a14="http://schemas.microsoft.com/office/drawing/2010/main" val="0"/>
+              </a:ext>
+            </a:extLst>
+          </a:blip>
+          <a:srcRect l="46864" t="25624" b="49881"/>
+          <a:stretch/>
+        </p:blipFill>
+        <p:spPr bwMode="auto">
+          <a:xfrm>
+            <a:off x="0" y="3010725"/>
+            <a:ext cx="3533775" cy="2496312"/>
+          </a:xfrm>
+          <a:prstGeom prst="rect">
+            <a:avLst/>
+          </a:prstGeom>
+          <a:noFill/>
+          <a:ln>
+            <a:noFill/>
+          </a:ln>
+        </p:spPr>
+      </p:pic>
     </p:spTree>
     <p:extLst>
       <p:ext uri="{BB962C8B-B14F-4D97-AF65-F5344CB8AC3E}">
-        <p14:creationId xmlns:p14="http://schemas.microsoft.com/office/powerpoint/2010/main" val="3840740628"/>
+        <p14:creationId xmlns:p14="http://schemas.microsoft.com/office/powerpoint/2010/main" val="3030411423"/>
       </p:ext>
     </p:extLst>
   </p:cSld>

</xml_diff>